<commit_message>
Regenerate sprint48_slide.pptx with Fira Sans font at size 17
- Switch all text from Calibri to Fira Sans
- Body/item text: 17pt normal, status labels: 17pt bold, feature headings: 19pt, category headers: 22pt
- Adjusted row heights and layout proportions to match larger font sizes

Co-Authored-By: Claude Sonnet 4.6 <noreply@anthropic.com>
Claude-Session: https://claude.ai/code/session_01NuVWMy893ggRmNAMjfvrnm
</commit_message>
<xml_diff>
--- a/sprint48_slide.pptx
+++ b/sprint48_slide.pptx
@@ -3098,7 +3098,7 @@
         <p:spPr>
           <a:xfrm>
             <a:off x="0" y="0"/>
-            <a:ext cx="12188952" cy="658368"/>
+            <a:ext cx="12188952" cy="749808"/>
           </a:xfrm>
           <a:prstGeom prst="rect">
             <a:avLst/>
@@ -3141,7 +3141,7 @@
         <p:spPr>
           <a:xfrm>
             <a:off x="0" y="0"/>
-            <a:ext cx="64008" cy="658368"/>
+            <a:ext cx="82296" cy="749808"/>
           </a:xfrm>
           <a:prstGeom prst="rect">
             <a:avLst/>
@@ -3183,8 +3183,8 @@
         </p:nvSpPr>
         <p:spPr>
           <a:xfrm>
-            <a:off x="164592" y="54864"/>
-            <a:ext cx="8686800" cy="274320"/>
+            <a:off x="201168" y="64008"/>
+            <a:ext cx="8686800" cy="347472"/>
           </a:xfrm>
           <a:prstGeom prst="rect">
             <a:avLst/>
@@ -3199,11 +3199,11 @@
           <a:p>
             <a:pPr algn="l"/>
             <a:r>
-              <a:rPr sz="1300" b="1" i="0">
+              <a:rPr sz="2000" b="1" i="0">
                 <a:solidFill>
                   <a:srgbClr val="FFFFFF"/>
                 </a:solidFill>
-                <a:latin typeface="Calibri"/>
+                <a:latin typeface="Fira Sans"/>
               </a:rPr>
               <a:t>Executive Summary – GD Core Team   Project Health:</a:t>
             </a:r>
@@ -3218,8 +3218,8 @@
         </p:nvSpPr>
         <p:spPr>
           <a:xfrm>
-            <a:off x="164592" y="338328"/>
-            <a:ext cx="6858000" cy="201168"/>
+            <a:off x="201168" y="420624"/>
+            <a:ext cx="7315200" cy="237744"/>
           </a:xfrm>
           <a:prstGeom prst="rect">
             <a:avLst/>
@@ -3234,11 +3234,11 @@
           <a:p>
             <a:pPr algn="l"/>
             <a:r>
-              <a:rPr sz="800" b="0" i="0">
+              <a:rPr sz="1300" b="0" i="0">
                 <a:solidFill>
                   <a:srgbClr val="BBDEFB"/>
                 </a:solidFill>
-                <a:latin typeface="Calibri"/>
+                <a:latin typeface="Fira Sans"/>
               </a:rPr>
               <a:t>Mars – Digital Health Transformation  ·  Sprint 48 · Jun 23 – Jul 6, 2026</a:t>
             </a:r>
@@ -3253,8 +3253,8 @@
         </p:nvSpPr>
         <p:spPr>
           <a:xfrm>
-            <a:off x="8961120" y="73152"/>
-            <a:ext cx="3063240" cy="201168"/>
+            <a:off x="8961120" y="91440"/>
+            <a:ext cx="3063240" cy="256032"/>
           </a:xfrm>
           <a:prstGeom prst="rect">
             <a:avLst/>
@@ -3269,11 +3269,11 @@
           <a:p>
             <a:pPr algn="r"/>
             <a:r>
-              <a:rPr sz="900" b="0" i="0">
+              <a:rPr sz="1400" b="0" i="0">
                 <a:solidFill>
                   <a:srgbClr val="FFFFFF"/>
                 </a:solidFill>
-                <a:latin typeface="Calibri"/>
+                <a:latin typeface="Fira Sans"/>
               </a:rPr>
               <a:t>www.griddynamics.com</a:t>
             </a:r>
@@ -3288,8 +3288,8 @@
         </p:nvSpPr>
         <p:spPr>
           <a:xfrm>
-            <a:off x="8961120" y="274320"/>
-            <a:ext cx="3063240" cy="201168"/>
+            <a:off x="8961120" y="365760"/>
+            <a:ext cx="3063240" cy="237744"/>
           </a:xfrm>
           <a:prstGeom prst="rect">
             <a:avLst/>
@@ -3304,11 +3304,11 @@
           <a:p>
             <a:pPr algn="r"/>
             <a:r>
-              <a:rPr sz="650" b="0" i="1">
+              <a:rPr sz="1000" b="0" i="1">
                 <a:solidFill>
                   <a:srgbClr val="BBDEFB"/>
                 </a:solidFill>
-                <a:latin typeface="Calibri"/>
+                <a:latin typeface="Fira Sans"/>
               </a:rPr>
               <a:t>trusted engineering partner for digital transformation</a:t>
             </a:r>
@@ -3323,8 +3323,8 @@
         </p:nvSpPr>
         <p:spPr>
           <a:xfrm>
-            <a:off x="11430000" y="173736"/>
-            <a:ext cx="384048" cy="274320"/>
+            <a:off x="11704320" y="201168"/>
+            <a:ext cx="365760" cy="292608"/>
           </a:xfrm>
           <a:prstGeom prst="rect">
             <a:avLst/>
@@ -3366,8 +3366,8 @@
         </p:nvSpPr>
         <p:spPr>
           <a:xfrm>
-            <a:off x="11430000" y="173736"/>
-            <a:ext cx="384048" cy="274320"/>
+            <a:off x="11704320" y="201168"/>
+            <a:ext cx="365760" cy="292608"/>
           </a:xfrm>
           <a:prstGeom prst="rect">
             <a:avLst/>
@@ -3382,11 +3382,11 @@
           <a:p>
             <a:pPr algn="ctr"/>
             <a:r>
-              <a:rPr sz="900" b="1" i="0">
+              <a:rPr sz="1400" b="1" i="0">
                 <a:solidFill>
                   <a:srgbClr val="FFFFFF"/>
                 </a:solidFill>
-                <a:latin typeface="Calibri"/>
+                <a:latin typeface="Fira Sans"/>
               </a:rPr>
               <a:t>3</a:t>
             </a:r>
@@ -3401,8 +3401,8 @@
         </p:nvSpPr>
         <p:spPr>
           <a:xfrm>
-            <a:off x="0" y="6583680"/>
-            <a:ext cx="12188952" cy="274320"/>
+            <a:off x="0" y="6537960"/>
+            <a:ext cx="12188952" cy="320040"/>
           </a:xfrm>
           <a:prstGeom prst="rect">
             <a:avLst/>
@@ -3444,8 +3444,8 @@
         </p:nvSpPr>
         <p:spPr>
           <a:xfrm>
-            <a:off x="0" y="6583680"/>
-            <a:ext cx="64008" cy="274320"/>
+            <a:off x="0" y="6537960"/>
+            <a:ext cx="82296" cy="320040"/>
           </a:xfrm>
           <a:prstGeom prst="rect">
             <a:avLst/>
@@ -3487,8 +3487,8 @@
         </p:nvSpPr>
         <p:spPr>
           <a:xfrm>
-            <a:off x="164592" y="6629400"/>
-            <a:ext cx="7772400" cy="201168"/>
+            <a:off x="201168" y="6601968"/>
+            <a:ext cx="7772400" cy="219456"/>
           </a:xfrm>
           <a:prstGeom prst="rect">
             <a:avLst/>
@@ -3503,11 +3503,11 @@
           <a:p>
             <a:pPr algn="l"/>
             <a:r>
-              <a:rPr sz="700" b="0" i="0">
+              <a:rPr sz="1100" b="0" i="0">
                 <a:solidFill>
                   <a:srgbClr val="BBDEFB"/>
                 </a:solidFill>
-                <a:latin typeface="Calibri"/>
+                <a:latin typeface="Fira Sans"/>
               </a:rPr>
               <a:t>Grid Dynamics / Mars – Digital Health Transformation / WSR – June 29, 2026</a:t>
             </a:r>
@@ -3522,8 +3522,8 @@
         </p:nvSpPr>
         <p:spPr>
           <a:xfrm>
-            <a:off x="8686800" y="6629400"/>
-            <a:ext cx="3337560" cy="201168"/>
+            <a:off x="8686800" y="6601968"/>
+            <a:ext cx="3337560" cy="219456"/>
           </a:xfrm>
           <a:prstGeom prst="rect">
             <a:avLst/>
@@ -3538,11 +3538,11 @@
           <a:p>
             <a:pPr algn="r"/>
             <a:r>
-              <a:rPr sz="700" b="0" i="0">
+              <a:rPr sz="1100" b="0" i="0">
                 <a:solidFill>
                   <a:srgbClr val="BBDEFB"/>
                 </a:solidFill>
-                <a:latin typeface="Calibri"/>
+                <a:latin typeface="Fira Sans"/>
               </a:rPr>
               <a:t>Privileged and confidential</a:t>
             </a:r>
@@ -3557,8 +3557,8 @@
         </p:nvSpPr>
         <p:spPr>
           <a:xfrm>
-            <a:off x="0" y="658368"/>
-            <a:ext cx="12188952" cy="5925312"/>
+            <a:off x="0" y="749808"/>
+            <a:ext cx="12188952" cy="5788152"/>
           </a:xfrm>
           <a:prstGeom prst="rect">
             <a:avLst/>
@@ -3600,8 +3600,8 @@
         </p:nvSpPr>
         <p:spPr>
           <a:xfrm>
-            <a:off x="91440" y="749808"/>
-            <a:ext cx="2864358" cy="22860"/>
+            <a:off x="118872" y="859536"/>
+            <a:ext cx="2809494" cy="27432"/>
           </a:xfrm>
           <a:prstGeom prst="rect">
             <a:avLst/>
@@ -3643,8 +3643,8 @@
         </p:nvSpPr>
         <p:spPr>
           <a:xfrm>
-            <a:off x="91440" y="777240"/>
-            <a:ext cx="2864358" cy="182880"/>
+            <a:off x="118872" y="896112"/>
+            <a:ext cx="2809494" cy="310896"/>
           </a:xfrm>
           <a:prstGeom prst="rect">
             <a:avLst/>
@@ -3659,11 +3659,11 @@
           <a:p>
             <a:pPr algn="l"/>
             <a:r>
-              <a:rPr sz="800" b="1" i="0">
+              <a:rPr sz="2200" b="1" i="0">
                 <a:solidFill>
                   <a:srgbClr val="1B2A4A"/>
                 </a:solidFill>
-                <a:latin typeface="Calibri"/>
+                <a:latin typeface="Fira Sans"/>
               </a:rPr>
               <a:t>TOOTHSCAN 2.0</a:t>
             </a:r>
@@ -3678,8 +3678,8 @@
         </p:nvSpPr>
         <p:spPr>
           <a:xfrm>
-            <a:off x="91440" y="960120"/>
-            <a:ext cx="2864358" cy="7315"/>
+            <a:off x="118872" y="1207008"/>
+            <a:ext cx="2809494" cy="9144"/>
           </a:xfrm>
           <a:prstGeom prst="rect">
             <a:avLst/>
@@ -3721,8 +3721,8 @@
         </p:nvSpPr>
         <p:spPr>
           <a:xfrm>
-            <a:off x="91440" y="978408"/>
-            <a:ext cx="2864358" cy="173736"/>
+            <a:off x="118872" y="1298448"/>
+            <a:ext cx="2809494" cy="274320"/>
           </a:xfrm>
           <a:prstGeom prst="rect">
             <a:avLst/>
@@ -3737,11 +3737,11 @@
           <a:p>
             <a:pPr algn="l"/>
             <a:r>
-              <a:rPr sz="850" b="1" i="0">
+              <a:rPr sz="1900" b="1" i="0">
                 <a:solidFill>
                   <a:srgbClr val="1A1A2E"/>
                 </a:solidFill>
-                <a:latin typeface="Calibri"/>
+                <a:latin typeface="Fira Sans"/>
               </a:rPr>
               <a:t>ToothScan 2.0 – Pet Parent Experience</a:t>
             </a:r>
@@ -3756,8 +3756,8 @@
         </p:nvSpPr>
         <p:spPr>
           <a:xfrm>
-            <a:off x="91440" y="1152144"/>
-            <a:ext cx="2864358" cy="146304"/>
+            <a:off x="118872" y="1572768"/>
+            <a:ext cx="2809494" cy="237744"/>
           </a:xfrm>
           <a:prstGeom prst="rect">
             <a:avLst/>
@@ -3771,20 +3771,20 @@
           <a:lstStyle/>
           <a:p>
             <a:r>
-              <a:rPr sz="750" b="1">
+              <a:rPr sz="1700" b="1">
                 <a:solidFill>
                   <a:srgbClr val="2E7D32"/>
                 </a:solidFill>
-                <a:latin typeface="Calibri"/>
+                <a:latin typeface="Fira Sans"/>
               </a:rPr>
               <a:t>● </a:t>
             </a:r>
             <a:r>
-              <a:rPr sz="750" b="1">
+              <a:rPr sz="1700" b="1">
                 <a:solidFill>
                   <a:srgbClr val="2E7D32"/>
                 </a:solidFill>
-                <a:latin typeface="Calibri"/>
+                <a:latin typeface="Fira Sans"/>
               </a:rPr>
               <a:t>COMPLETED</a:t>
             </a:r>
@@ -3799,8 +3799,8 @@
         </p:nvSpPr>
         <p:spPr>
           <a:xfrm>
-            <a:off x="219456" y="1298448"/>
-            <a:ext cx="2736341" cy="150875"/>
+            <a:off x="283464" y="1810512"/>
+            <a:ext cx="2644901" cy="256031"/>
           </a:xfrm>
           <a:prstGeom prst="rect">
             <a:avLst/>
@@ -3814,11 +3814,11 @@
           <a:lstStyle/>
           <a:p>
             <a:r>
-              <a:rPr sz="750" b="0">
+              <a:rPr sz="1700" b="0">
                 <a:solidFill>
                   <a:srgbClr val="3D3D3D"/>
                 </a:solidFill>
-                <a:latin typeface="Calibri"/>
+                <a:latin typeface="Fira Sans"/>
               </a:rPr>
               <a:t>Fixed content on welcome page &amp; fun fact page</a:t>
             </a:r>
@@ -3833,8 +3833,8 @@
         </p:nvSpPr>
         <p:spPr>
           <a:xfrm>
-            <a:off x="219456" y="1431036"/>
-            <a:ext cx="2736341" cy="150875"/>
+            <a:off x="283464" y="2029968"/>
+            <a:ext cx="2644901" cy="256031"/>
           </a:xfrm>
           <a:prstGeom prst="rect">
             <a:avLst/>
@@ -3848,11 +3848,11 @@
           <a:lstStyle/>
           <a:p>
             <a:r>
-              <a:rPr sz="750" b="0">
+              <a:rPr sz="1700" b="0">
                 <a:solidFill>
                   <a:srgbClr val="3D3D3D"/>
                 </a:solidFill>
-                <a:latin typeface="Calibri"/>
+                <a:latin typeface="Fira Sans"/>
               </a:rPr>
               <a:t>Resolved spacing issues in user questionnaire</a:t>
             </a:r>
@@ -3867,8 +3867,8 @@
         </p:nvSpPr>
         <p:spPr>
           <a:xfrm>
-            <a:off x="219456" y="1563624"/>
-            <a:ext cx="2736341" cy="150875"/>
+            <a:off x="283464" y="2249424"/>
+            <a:ext cx="2644901" cy="256031"/>
           </a:xfrm>
           <a:prstGeom prst="rect">
             <a:avLst/>
@@ -3882,11 +3882,11 @@
           <a:lstStyle/>
           <a:p>
             <a:r>
-              <a:rPr sz="750" b="0">
+              <a:rPr sz="1700" b="0">
                 <a:solidFill>
                   <a:srgbClr val="3D3D3D"/>
                 </a:solidFill>
-                <a:latin typeface="Calibri"/>
+                <a:latin typeface="Fira Sans"/>
               </a:rPr>
               <a:t>Restored back button on Additional Resources page</a:t>
             </a:r>
@@ -3901,8 +3901,8 @@
         </p:nvSpPr>
         <p:spPr>
           <a:xfrm>
-            <a:off x="219456" y="1696212"/>
-            <a:ext cx="2736341" cy="150875"/>
+            <a:off x="283464" y="2468880"/>
+            <a:ext cx="2644901" cy="256031"/>
           </a:xfrm>
           <a:prstGeom prst="rect">
             <a:avLst/>
@@ -3916,11 +3916,11 @@
           <a:lstStyle/>
           <a:p>
             <a:r>
-              <a:rPr sz="750" b="0">
+              <a:rPr sz="1700" b="0">
                 <a:solidFill>
                   <a:srgbClr val="3D3D3D"/>
                 </a:solidFill>
-                <a:latin typeface="Calibri"/>
+                <a:latin typeface="Fira Sans"/>
               </a:rPr>
               <a:t>Resolved mobile Stage testing observations</a:t>
             </a:r>
@@ -3935,8 +3935,8 @@
         </p:nvSpPr>
         <p:spPr>
           <a:xfrm>
-            <a:off x="91440" y="1828800"/>
-            <a:ext cx="2864358" cy="146304"/>
+            <a:off x="118872" y="2688336"/>
+            <a:ext cx="2809494" cy="237744"/>
           </a:xfrm>
           <a:prstGeom prst="rect">
             <a:avLst/>
@@ -3950,20 +3950,20 @@
           <a:lstStyle/>
           <a:p>
             <a:r>
-              <a:rPr sz="750" b="1">
+              <a:rPr sz="1700" b="1">
                 <a:solidFill>
                   <a:srgbClr val="E65100"/>
                 </a:solidFill>
-                <a:latin typeface="Calibri"/>
+                <a:latin typeface="Fira Sans"/>
               </a:rPr>
               <a:t>● </a:t>
             </a:r>
             <a:r>
-              <a:rPr sz="750" b="1">
+              <a:rPr sz="1700" b="1">
                 <a:solidFill>
                   <a:srgbClr val="E65100"/>
                 </a:solidFill>
-                <a:latin typeface="Calibri"/>
+                <a:latin typeface="Fira Sans"/>
               </a:rPr>
               <a:t>QA / TESTING</a:t>
             </a:r>
@@ -3978,8 +3978,8 @@
         </p:nvSpPr>
         <p:spPr>
           <a:xfrm>
-            <a:off x="219456" y="1975104"/>
-            <a:ext cx="2736341" cy="150875"/>
+            <a:off x="283464" y="2926080"/>
+            <a:ext cx="2644901" cy="402336"/>
           </a:xfrm>
           <a:prstGeom prst="rect">
             <a:avLst/>
@@ -3993,11 +3993,11 @@
           <a:lstStyle/>
           <a:p>
             <a:r>
-              <a:rPr sz="750" b="0">
+              <a:rPr sz="1700" b="0">
                 <a:solidFill>
                   <a:srgbClr val="3D3D3D"/>
                 </a:solidFill>
-                <a:latin typeface="Calibri"/>
+                <a:latin typeface="Fira Sans"/>
               </a:rPr>
               <a:t>Config ID stored in Outcomes DB – ToothScan tool updated</a:t>
             </a:r>
@@ -4012,8 +4012,8 @@
         </p:nvSpPr>
         <p:spPr>
           <a:xfrm>
-            <a:off x="219456" y="2107692"/>
-            <a:ext cx="2736341" cy="150875"/>
+            <a:off x="283464" y="3291840"/>
+            <a:ext cx="2644901" cy="256031"/>
           </a:xfrm>
           <a:prstGeom prst="rect">
             <a:avLst/>
@@ -4027,11 +4027,11 @@
           <a:lstStyle/>
           <a:p>
             <a:r>
-              <a:rPr sz="750" b="0">
+              <a:rPr sz="1700" b="0">
                 <a:solidFill>
                   <a:srgbClr val="3D3D3D"/>
                 </a:solidFill>
-                <a:latin typeface="Calibri"/>
+                <a:latin typeface="Fira Sans"/>
               </a:rPr>
               <a:t>CAS updated to persist Config ID in outcomes</a:t>
             </a:r>
@@ -4046,8 +4046,8 @@
         </p:nvSpPr>
         <p:spPr>
           <a:xfrm>
-            <a:off x="219456" y="2240280"/>
-            <a:ext cx="2736341" cy="150875"/>
+            <a:off x="283464" y="3511296"/>
+            <a:ext cx="2644901" cy="256031"/>
           </a:xfrm>
           <a:prstGeom prst="rect">
             <a:avLst/>
@@ -4061,11 +4061,11 @@
           <a:lstStyle/>
           <a:p>
             <a:r>
-              <a:rPr sz="750" b="0">
+              <a:rPr sz="1700" b="0">
                 <a:solidFill>
                   <a:srgbClr val="3D3D3D"/>
                 </a:solidFill>
-                <a:latin typeface="Calibri"/>
+                <a:latin typeface="Fira Sans"/>
               </a:rPr>
               <a:t>App context updated with Config ID across all tools</a:t>
             </a:r>
@@ -4080,8 +4080,8 @@
         </p:nvSpPr>
         <p:spPr>
           <a:xfrm>
-            <a:off x="91440" y="2372868"/>
-            <a:ext cx="2864358" cy="146304"/>
+            <a:off x="118872" y="3730752"/>
+            <a:ext cx="2809494" cy="237744"/>
           </a:xfrm>
           <a:prstGeom prst="rect">
             <a:avLst/>
@@ -4095,20 +4095,20 @@
           <a:lstStyle/>
           <a:p>
             <a:r>
-              <a:rPr sz="750" b="1">
+              <a:rPr sz="1700" b="1">
                 <a:solidFill>
                   <a:srgbClr val="1565C0"/>
                 </a:solidFill>
-                <a:latin typeface="Calibri"/>
+                <a:latin typeface="Fira Sans"/>
               </a:rPr>
               <a:t>● </a:t>
             </a:r>
             <a:r>
-              <a:rPr sz="750" b="1">
+              <a:rPr sz="1700" b="1">
                 <a:solidFill>
                   <a:srgbClr val="1565C0"/>
                 </a:solidFill>
-                <a:latin typeface="Calibri"/>
+                <a:latin typeface="Fira Sans"/>
               </a:rPr>
               <a:t>IN PROGRESS</a:t>
             </a:r>
@@ -4123,8 +4123,8 @@
         </p:nvSpPr>
         <p:spPr>
           <a:xfrm>
-            <a:off x="219456" y="2519172"/>
-            <a:ext cx="2736341" cy="150875"/>
+            <a:off x="283464" y="3968496"/>
+            <a:ext cx="2644901" cy="256031"/>
           </a:xfrm>
           <a:prstGeom prst="rect">
             <a:avLst/>
@@ -4138,11 +4138,11 @@
           <a:lstStyle/>
           <a:p>
             <a:r>
-              <a:rPr sz="750" b="0">
+              <a:rPr sz="1700" b="0">
                 <a:solidFill>
                   <a:srgbClr val="3D3D3D"/>
                 </a:solidFill>
-                <a:latin typeface="Calibri"/>
+                <a:latin typeface="Fira Sans"/>
               </a:rPr>
               <a:t>User Journey deployment to Preprod &amp; Production</a:t>
             </a:r>
@@ -4157,8 +4157,8 @@
         </p:nvSpPr>
         <p:spPr>
           <a:xfrm>
-            <a:off x="219456" y="2651760"/>
-            <a:ext cx="2736341" cy="150875"/>
+            <a:off x="283464" y="4187952"/>
+            <a:ext cx="2644901" cy="256031"/>
           </a:xfrm>
           <a:prstGeom prst="rect">
             <a:avLst/>
@@ -4172,11 +4172,11 @@
           <a:lstStyle/>
           <a:p>
             <a:r>
-              <a:rPr sz="750" b="0">
+              <a:rPr sz="1700" b="0">
                 <a:solidFill>
                   <a:srgbClr val="3D3D3D"/>
                 </a:solidFill>
-                <a:latin typeface="Calibri"/>
+                <a:latin typeface="Fira Sans"/>
               </a:rPr>
               <a:t>Backend logger error resolution in ToothScan service</a:t>
             </a:r>
@@ -4191,8 +4191,8 @@
         </p:nvSpPr>
         <p:spPr>
           <a:xfrm>
-            <a:off x="91440" y="2784348"/>
-            <a:ext cx="2864358" cy="146304"/>
+            <a:off x="118872" y="4407408"/>
+            <a:ext cx="2809494" cy="237744"/>
           </a:xfrm>
           <a:prstGeom prst="rect">
             <a:avLst/>
@@ -4206,20 +4206,20 @@
           <a:lstStyle/>
           <a:p>
             <a:r>
-              <a:rPr sz="750" b="1">
+              <a:rPr sz="1700" b="1">
                 <a:solidFill>
                   <a:srgbClr val="555555"/>
                 </a:solidFill>
-                <a:latin typeface="Calibri"/>
+                <a:latin typeface="Fira Sans"/>
               </a:rPr>
               <a:t>● </a:t>
             </a:r>
             <a:r>
-              <a:rPr sz="750" b="1">
+              <a:rPr sz="1700" b="1">
                 <a:solidFill>
                   <a:srgbClr val="555555"/>
                 </a:solidFill>
-                <a:latin typeface="Calibri"/>
+                <a:latin typeface="Fira Sans"/>
               </a:rPr>
               <a:t>PLANNED</a:t>
             </a:r>
@@ -4234,8 +4234,8 @@
         </p:nvSpPr>
         <p:spPr>
           <a:xfrm>
-            <a:off x="219456" y="2930652"/>
-            <a:ext cx="2736341" cy="150875"/>
+            <a:off x="283464" y="4645152"/>
+            <a:ext cx="2644901" cy="256031"/>
           </a:xfrm>
           <a:prstGeom prst="rect">
             <a:avLst/>
@@ -4249,11 +4249,11 @@
           <a:lstStyle/>
           <a:p>
             <a:r>
-              <a:rPr sz="750" b="0">
+              <a:rPr sz="1700" b="0">
                 <a:solidFill>
                   <a:srgbClr val="3D3D3D"/>
                 </a:solidFill>
-                <a:latin typeface="Calibri"/>
+                <a:latin typeface="Fira Sans"/>
               </a:rPr>
               <a:t>Updated image upload error screens (new Figma designs)</a:t>
             </a:r>
@@ -4268,8 +4268,8 @@
         </p:nvSpPr>
         <p:spPr>
           <a:xfrm>
-            <a:off x="219456" y="3063240"/>
-            <a:ext cx="2736341" cy="150875"/>
+            <a:off x="283464" y="4864608"/>
+            <a:ext cx="2644901" cy="256031"/>
           </a:xfrm>
           <a:prstGeom prst="rect">
             <a:avLst/>
@@ -4283,11 +4283,11 @@
           <a:lstStyle/>
           <a:p>
             <a:r>
-              <a:rPr sz="750" b="0">
+              <a:rPr sz="1700" b="0">
                 <a:solidFill>
                   <a:srgbClr val="3D3D3D"/>
                 </a:solidFill>
-                <a:latin typeface="Calibri"/>
+                <a:latin typeface="Fira Sans"/>
               </a:rPr>
               <a:t>Validation messages display fix on preview screen</a:t>
             </a:r>
@@ -4302,8 +4302,8 @@
         </p:nvSpPr>
         <p:spPr>
           <a:xfrm>
-            <a:off x="219456" y="3195828"/>
-            <a:ext cx="2736341" cy="150875"/>
+            <a:off x="283464" y="5084064"/>
+            <a:ext cx="2644901" cy="256031"/>
           </a:xfrm>
           <a:prstGeom prst="rect">
             <a:avLst/>
@@ -4317,11 +4317,11 @@
           <a:lstStyle/>
           <a:p>
             <a:r>
-              <a:rPr sz="750" b="0">
+              <a:rPr sz="1700" b="0">
                 <a:solidFill>
                   <a:srgbClr val="3D3D3D"/>
                 </a:solidFill>
-                <a:latin typeface="Calibri"/>
+                <a:latin typeface="Fira Sans"/>
               </a:rPr>
               <a:t>Image Not Found error handling on user submission</a:t>
             </a:r>
@@ -4336,8 +4336,8 @@
         </p:nvSpPr>
         <p:spPr>
           <a:xfrm>
-            <a:off x="219456" y="3328416"/>
-            <a:ext cx="2736341" cy="150875"/>
+            <a:off x="283464" y="5303520"/>
+            <a:ext cx="2644901" cy="256031"/>
           </a:xfrm>
           <a:prstGeom prst="rect">
             <a:avLst/>
@@ -4351,11 +4351,11 @@
           <a:lstStyle/>
           <a:p>
             <a:r>
-              <a:rPr sz="750" b="0">
+              <a:rPr sz="1700" b="0">
                 <a:solidFill>
                   <a:srgbClr val="3D3D3D"/>
                 </a:solidFill>
-                <a:latin typeface="Calibri"/>
+                <a:latin typeface="Fira Sans"/>
               </a:rPr>
               <a:t>Clickable option display correction on preview screen</a:t>
             </a:r>
@@ -4370,8 +4370,8 @@
         </p:nvSpPr>
         <p:spPr>
           <a:xfrm>
-            <a:off x="3047238" y="658368"/>
-            <a:ext cx="10972" cy="5925312"/>
+            <a:off x="3047238" y="749808"/>
+            <a:ext cx="10972" cy="5788152"/>
           </a:xfrm>
           <a:prstGeom prst="rect">
             <a:avLst/>
@@ -4413,8 +4413,8 @@
         </p:nvSpPr>
         <p:spPr>
           <a:xfrm>
-            <a:off x="3138678" y="749808"/>
-            <a:ext cx="2864358" cy="22860"/>
+            <a:off x="3166110" y="859536"/>
+            <a:ext cx="2809494" cy="27432"/>
           </a:xfrm>
           <a:prstGeom prst="rect">
             <a:avLst/>
@@ -4456,8 +4456,8 @@
         </p:nvSpPr>
         <p:spPr>
           <a:xfrm>
-            <a:off x="3138678" y="777240"/>
-            <a:ext cx="2864358" cy="182880"/>
+            <a:off x="3166110" y="896112"/>
+            <a:ext cx="2809494" cy="310896"/>
           </a:xfrm>
           <a:prstGeom prst="rect">
             <a:avLst/>
@@ -4472,11 +4472,11 @@
           <a:p>
             <a:pPr algn="l"/>
             <a:r>
-              <a:rPr sz="800" b="1" i="0">
+              <a:rPr sz="2200" b="1" i="0">
                 <a:solidFill>
                   <a:srgbClr val="1B2A4A"/>
                 </a:solidFill>
-                <a:latin typeface="Calibri"/>
+                <a:latin typeface="Fira Sans"/>
               </a:rPr>
               <a:t>SDK – JOURNEY NAVIGATION</a:t>
             </a:r>
@@ -4491,8 +4491,8 @@
         </p:nvSpPr>
         <p:spPr>
           <a:xfrm>
-            <a:off x="3138678" y="960120"/>
-            <a:ext cx="2864358" cy="7315"/>
+            <a:off x="3166110" y="1207008"/>
+            <a:ext cx="2809494" cy="9144"/>
           </a:xfrm>
           <a:prstGeom prst="rect">
             <a:avLst/>
@@ -4534,8 +4534,8 @@
         </p:nvSpPr>
         <p:spPr>
           <a:xfrm>
-            <a:off x="3138678" y="978408"/>
-            <a:ext cx="2864358" cy="173736"/>
+            <a:off x="3166110" y="1298448"/>
+            <a:ext cx="2809494" cy="274320"/>
           </a:xfrm>
           <a:prstGeom prst="rect">
             <a:avLst/>
@@ -4550,11 +4550,11 @@
           <a:p>
             <a:pPr algn="l"/>
             <a:r>
-              <a:rPr sz="850" b="1" i="0">
+              <a:rPr sz="1900" b="1" i="0">
                 <a:solidFill>
                   <a:srgbClr val="1A1A2E"/>
                 </a:solidFill>
-                <a:latin typeface="Calibri"/>
+                <a:latin typeface="Fira Sans"/>
               </a:rPr>
               <a:t>Configurable Journey Navigation</a:t>
             </a:r>
@@ -4569,8 +4569,8 @@
         </p:nvSpPr>
         <p:spPr>
           <a:xfrm>
-            <a:off x="3138678" y="1152144"/>
-            <a:ext cx="2864358" cy="146304"/>
+            <a:off x="3166110" y="1572768"/>
+            <a:ext cx="2809494" cy="237744"/>
           </a:xfrm>
           <a:prstGeom prst="rect">
             <a:avLst/>
@@ -4584,20 +4584,20 @@
           <a:lstStyle/>
           <a:p>
             <a:r>
-              <a:rPr sz="750" b="1">
+              <a:rPr sz="1700" b="1">
                 <a:solidFill>
                   <a:srgbClr val="2E7D32"/>
                 </a:solidFill>
-                <a:latin typeface="Calibri"/>
+                <a:latin typeface="Fira Sans"/>
               </a:rPr>
               <a:t>● </a:t>
             </a:r>
             <a:r>
-              <a:rPr sz="750" b="1">
+              <a:rPr sz="1700" b="1">
                 <a:solidFill>
                   <a:srgbClr val="2E7D32"/>
                 </a:solidFill>
-                <a:latin typeface="Calibri"/>
+                <a:latin typeface="Fira Sans"/>
               </a:rPr>
               <a:t>COMPLETED</a:t>
             </a:r>
@@ -4612,8 +4612,8 @@
         </p:nvSpPr>
         <p:spPr>
           <a:xfrm>
-            <a:off x="3266694" y="1298448"/>
-            <a:ext cx="2736341" cy="150875"/>
+            <a:off x="3330702" y="1810512"/>
+            <a:ext cx="2644901" cy="256031"/>
           </a:xfrm>
           <a:prstGeom prst="rect">
             <a:avLst/>
@@ -4627,11 +4627,11 @@
           <a:lstStyle/>
           <a:p>
             <a:r>
-              <a:rPr sz="750" b="0">
+              <a:rPr sz="1700" b="0">
                 <a:solidFill>
                   <a:srgbClr val="3D3D3D"/>
                 </a:solidFill>
-                <a:latin typeface="Calibri"/>
+                <a:latin typeface="Fira Sans"/>
               </a:rPr>
               <a:t>Navigation Rules save validation delivered</a:t>
             </a:r>
@@ -4646,8 +4646,8 @@
         </p:nvSpPr>
         <p:spPr>
           <a:xfrm>
-            <a:off x="3266694" y="1431036"/>
-            <a:ext cx="2736341" cy="150875"/>
+            <a:off x="3330702" y="2029968"/>
+            <a:ext cx="2644901" cy="256031"/>
           </a:xfrm>
           <a:prstGeom prst="rect">
             <a:avLst/>
@@ -4661,11 +4661,11 @@
           <a:lstStyle/>
           <a:p>
             <a:r>
-              <a:rPr sz="750" b="0">
+              <a:rPr sz="1700" b="0">
                 <a:solidFill>
                   <a:srgbClr val="3D3D3D"/>
                 </a:solidFill>
-                <a:latin typeface="Calibri"/>
+                <a:latin typeface="Fira Sans"/>
               </a:rPr>
               <a:t>Navigation Rules &amp; View Conditions schema completed</a:t>
             </a:r>
@@ -4680,8 +4680,8 @@
         </p:nvSpPr>
         <p:spPr>
           <a:xfrm>
-            <a:off x="3138678" y="1563624"/>
-            <a:ext cx="2864358" cy="146304"/>
+            <a:off x="3166110" y="2249424"/>
+            <a:ext cx="2809494" cy="237744"/>
           </a:xfrm>
           <a:prstGeom prst="rect">
             <a:avLst/>
@@ -4695,20 +4695,20 @@
           <a:lstStyle/>
           <a:p>
             <a:r>
-              <a:rPr sz="750" b="1">
+              <a:rPr sz="1700" b="1">
                 <a:solidFill>
                   <a:srgbClr val="1565C0"/>
                 </a:solidFill>
-                <a:latin typeface="Calibri"/>
+                <a:latin typeface="Fira Sans"/>
               </a:rPr>
               <a:t>● </a:t>
             </a:r>
             <a:r>
-              <a:rPr sz="750" b="1">
+              <a:rPr sz="1700" b="1">
                 <a:solidFill>
                   <a:srgbClr val="1565C0"/>
                 </a:solidFill>
-                <a:latin typeface="Calibri"/>
+                <a:latin typeface="Fira Sans"/>
               </a:rPr>
               <a:t>IN PROGRESS</a:t>
             </a:r>
@@ -4723,8 +4723,8 @@
         </p:nvSpPr>
         <p:spPr>
           <a:xfrm>
-            <a:off x="3266694" y="1709928"/>
-            <a:ext cx="2736341" cy="150875"/>
+            <a:off x="3330702" y="2487168"/>
+            <a:ext cx="2644901" cy="256031"/>
           </a:xfrm>
           <a:prstGeom prst="rect">
             <a:avLst/>
@@ -4738,11 +4738,11 @@
           <a:lstStyle/>
           <a:p>
             <a:r>
-              <a:rPr sz="750" b="0">
+              <a:rPr sz="1700" b="0">
                 <a:solidFill>
                   <a:srgbClr val="3D3D3D"/>
                 </a:solidFill>
-                <a:latin typeface="Calibri"/>
+                <a:latin typeface="Fira Sans"/>
               </a:rPr>
               <a:t>UX design for navigation rules in SDK Manager</a:t>
             </a:r>
@@ -4757,8 +4757,8 @@
         </p:nvSpPr>
         <p:spPr>
           <a:xfrm>
-            <a:off x="3266694" y="1842515"/>
-            <a:ext cx="2736341" cy="150875"/>
+            <a:off x="3330702" y="2706624"/>
+            <a:ext cx="2644901" cy="256031"/>
           </a:xfrm>
           <a:prstGeom prst="rect">
             <a:avLst/>
@@ -4772,11 +4772,11 @@
           <a:lstStyle/>
           <a:p>
             <a:r>
-              <a:rPr sz="750" b="0">
+              <a:rPr sz="1700" b="0">
                 <a:solidFill>
                   <a:srgbClr val="3D3D3D"/>
                 </a:solidFill>
-                <a:latin typeface="Calibri"/>
+                <a:latin typeface="Fira Sans"/>
               </a:rPr>
               <a:t>Screen lifecycle actions in Screen Builder (FE)</a:t>
             </a:r>
@@ -4791,8 +4791,8 @@
         </p:nvSpPr>
         <p:spPr>
           <a:xfrm>
-            <a:off x="3138678" y="1975103"/>
-            <a:ext cx="2864358" cy="146304"/>
+            <a:off x="3166110" y="2926080"/>
+            <a:ext cx="2809494" cy="237744"/>
           </a:xfrm>
           <a:prstGeom prst="rect">
             <a:avLst/>
@@ -4806,20 +4806,20 @@
           <a:lstStyle/>
           <a:p>
             <a:r>
-              <a:rPr sz="750" b="1">
+              <a:rPr sz="1700" b="1">
                 <a:solidFill>
                   <a:srgbClr val="555555"/>
                 </a:solidFill>
-                <a:latin typeface="Calibri"/>
+                <a:latin typeface="Fira Sans"/>
               </a:rPr>
               <a:t>● </a:t>
             </a:r>
             <a:r>
-              <a:rPr sz="750" b="1">
+              <a:rPr sz="1700" b="1">
                 <a:solidFill>
                   <a:srgbClr val="555555"/>
                 </a:solidFill>
-                <a:latin typeface="Calibri"/>
+                <a:latin typeface="Fira Sans"/>
               </a:rPr>
               <a:t>PLANNED</a:t>
             </a:r>
@@ -4834,8 +4834,8 @@
         </p:nvSpPr>
         <p:spPr>
           <a:xfrm>
-            <a:off x="3266694" y="2121408"/>
-            <a:ext cx="2736341" cy="150875"/>
+            <a:off x="3330702" y="3163824"/>
+            <a:ext cx="2644901" cy="256031"/>
           </a:xfrm>
           <a:prstGeom prst="rect">
             <a:avLst/>
@@ -4849,11 +4849,11 @@
           <a:lstStyle/>
           <a:p>
             <a:r>
-              <a:rPr sz="750" b="0">
+              <a:rPr sz="1700" b="0">
                 <a:solidFill>
                   <a:srgbClr val="3D3D3D"/>
                 </a:solidFill>
-                <a:latin typeface="Calibri"/>
+                <a:latin typeface="Fira Sans"/>
               </a:rPr>
               <a:t>Screen lifecycle actions execution in SDK runtime</a:t>
             </a:r>
@@ -4868,8 +4868,8 @@
         </p:nvSpPr>
         <p:spPr>
           <a:xfrm>
-            <a:off x="3266694" y="2253996"/>
-            <a:ext cx="2736341" cy="150875"/>
+            <a:off x="3330702" y="3383280"/>
+            <a:ext cx="2644901" cy="256031"/>
           </a:xfrm>
           <a:prstGeom prst="rect">
             <a:avLst/>
@@ -4883,11 +4883,11 @@
           <a:lstStyle/>
           <a:p>
             <a:r>
-              <a:rPr sz="750" b="0">
+              <a:rPr sz="1700" b="0">
                 <a:solidFill>
                   <a:srgbClr val="3D3D3D"/>
                 </a:solidFill>
-                <a:latin typeface="Calibri"/>
+                <a:latin typeface="Fira Sans"/>
               </a:rPr>
               <a:t>Idempotent outcome persistence for lifecycle actions</a:t>
             </a:r>
@@ -4902,8 +4902,8 @@
         </p:nvSpPr>
         <p:spPr>
           <a:xfrm>
-            <a:off x="6094476" y="658368"/>
-            <a:ext cx="10972" cy="5925312"/>
+            <a:off x="6094476" y="749808"/>
+            <a:ext cx="10972" cy="5788152"/>
           </a:xfrm>
           <a:prstGeom prst="rect">
             <a:avLst/>
@@ -4945,8 +4945,8 @@
         </p:nvSpPr>
         <p:spPr>
           <a:xfrm>
-            <a:off x="6185916" y="749808"/>
-            <a:ext cx="2864358" cy="22860"/>
+            <a:off x="6213348" y="859536"/>
+            <a:ext cx="2809494" cy="27432"/>
           </a:xfrm>
           <a:prstGeom prst="rect">
             <a:avLst/>
@@ -4988,8 +4988,8 @@
         </p:nvSpPr>
         <p:spPr>
           <a:xfrm>
-            <a:off x="6185916" y="777240"/>
-            <a:ext cx="2864358" cy="182880"/>
+            <a:off x="6213348" y="896112"/>
+            <a:ext cx="2809494" cy="310896"/>
           </a:xfrm>
           <a:prstGeom prst="rect">
             <a:avLst/>
@@ -5004,11 +5004,11 @@
           <a:p>
             <a:pPr algn="l"/>
             <a:r>
-              <a:rPr sz="800" b="1" i="0">
+              <a:rPr sz="2200" b="1" i="0">
                 <a:solidFill>
                   <a:srgbClr val="1B2A4A"/>
                 </a:solidFill>
-                <a:latin typeface="Calibri"/>
+                <a:latin typeface="Fira Sans"/>
               </a:rPr>
               <a:t>SDK – CONFIG ID BUNDLES</a:t>
             </a:r>
@@ -5023,8 +5023,8 @@
         </p:nvSpPr>
         <p:spPr>
           <a:xfrm>
-            <a:off x="6185916" y="960120"/>
-            <a:ext cx="2864358" cy="7315"/>
+            <a:off x="6213348" y="1207008"/>
+            <a:ext cx="2809494" cy="9144"/>
           </a:xfrm>
           <a:prstGeom prst="rect">
             <a:avLst/>
@@ -5066,8 +5066,8 @@
         </p:nvSpPr>
         <p:spPr>
           <a:xfrm>
-            <a:off x="6185916" y="978408"/>
-            <a:ext cx="2864358" cy="173736"/>
+            <a:off x="6213348" y="1298448"/>
+            <a:ext cx="2809494" cy="274320"/>
           </a:xfrm>
           <a:prstGeom prst="rect">
             <a:avLst/>
@@ -5082,11 +5082,11 @@
           <a:p>
             <a:pPr algn="l"/>
             <a:r>
-              <a:rPr sz="850" b="1" i="0">
+              <a:rPr sz="1900" b="1" i="0">
                 <a:solidFill>
                   <a:srgbClr val="1A1A2E"/>
                 </a:solidFill>
-                <a:latin typeface="Calibri"/>
+                <a:latin typeface="Fira Sans"/>
               </a:rPr>
               <a:t>Config ID Bundle Management</a:t>
             </a:r>
@@ -5101,8 +5101,8 @@
         </p:nvSpPr>
         <p:spPr>
           <a:xfrm>
-            <a:off x="6185916" y="1152144"/>
-            <a:ext cx="2864358" cy="146304"/>
+            <a:off x="6213348" y="1572768"/>
+            <a:ext cx="2809494" cy="237744"/>
           </a:xfrm>
           <a:prstGeom prst="rect">
             <a:avLst/>
@@ -5116,20 +5116,20 @@
           <a:lstStyle/>
           <a:p>
             <a:r>
-              <a:rPr sz="750" b="1">
+              <a:rPr sz="1700" b="1">
                 <a:solidFill>
                   <a:srgbClr val="1565C0"/>
                 </a:solidFill>
-                <a:latin typeface="Calibri"/>
+                <a:latin typeface="Fira Sans"/>
               </a:rPr>
               <a:t>● </a:t>
             </a:r>
             <a:r>
-              <a:rPr sz="750" b="1">
+              <a:rPr sz="1700" b="1">
                 <a:solidFill>
                   <a:srgbClr val="1565C0"/>
                 </a:solidFill>
-                <a:latin typeface="Calibri"/>
+                <a:latin typeface="Fira Sans"/>
               </a:rPr>
               <a:t>IN PROGRESS</a:t>
             </a:r>
@@ -5144,8 +5144,8 @@
         </p:nvSpPr>
         <p:spPr>
           <a:xfrm>
-            <a:off x="6313931" y="1298448"/>
-            <a:ext cx="2736341" cy="150875"/>
+            <a:off x="6377940" y="1810512"/>
+            <a:ext cx="2644901" cy="256031"/>
           </a:xfrm>
           <a:prstGeom prst="rect">
             <a:avLst/>
@@ -5159,11 +5159,11 @@
           <a:lstStyle/>
           <a:p>
             <a:r>
-              <a:rPr sz="750" b="0">
+              <a:rPr sz="1700" b="0">
                 <a:solidFill>
                   <a:srgbClr val="3D3D3D"/>
                 </a:solidFill>
-                <a:latin typeface="Calibri"/>
+                <a:latin typeface="Fira Sans"/>
               </a:rPr>
               <a:t>Configuration history integration design</a:t>
             </a:r>
@@ -5178,8 +5178,8 @@
         </p:nvSpPr>
         <p:spPr>
           <a:xfrm>
-            <a:off x="6313931" y="1431036"/>
-            <a:ext cx="2736341" cy="150875"/>
+            <a:off x="6377940" y="2029968"/>
+            <a:ext cx="2644901" cy="256031"/>
           </a:xfrm>
           <a:prstGeom prst="rect">
             <a:avLst/>
@@ -5193,11 +5193,11 @@
           <a:lstStyle/>
           <a:p>
             <a:r>
-              <a:rPr sz="750" b="0">
+              <a:rPr sz="1700" b="0">
                 <a:solidFill>
                   <a:srgbClr val="3D3D3D"/>
                 </a:solidFill>
-                <a:latin typeface="Calibri"/>
+                <a:latin typeface="Fira Sans"/>
               </a:rPr>
               <a:t>Configuration variants relationship design</a:t>
             </a:r>
@@ -5212,8 +5212,8 @@
         </p:nvSpPr>
         <p:spPr>
           <a:xfrm>
-            <a:off x="6185916" y="1636776"/>
-            <a:ext cx="2864358" cy="173736"/>
+            <a:off x="6213348" y="2377440"/>
+            <a:ext cx="2809494" cy="274320"/>
           </a:xfrm>
           <a:prstGeom prst="rect">
             <a:avLst/>
@@ -5228,11 +5228,11 @@
           <a:p>
             <a:pPr algn="l"/>
             <a:r>
-              <a:rPr sz="850" b="1" i="0">
+              <a:rPr sz="1900" b="1" i="0">
                 <a:solidFill>
                   <a:srgbClr val="1A1A2E"/>
                 </a:solidFill>
-                <a:latin typeface="Calibri"/>
+                <a:latin typeface="Fira Sans"/>
               </a:rPr>
               <a:t>Edit Sub Brand</a:t>
             </a:r>
@@ -5247,8 +5247,8 @@
         </p:nvSpPr>
         <p:spPr>
           <a:xfrm>
-            <a:off x="6185916" y="1810512"/>
-            <a:ext cx="2864358" cy="146304"/>
+            <a:off x="6213348" y="2651760"/>
+            <a:ext cx="2809494" cy="237744"/>
           </a:xfrm>
           <a:prstGeom prst="rect">
             <a:avLst/>
@@ -5262,20 +5262,20 @@
           <a:lstStyle/>
           <a:p>
             <a:r>
-              <a:rPr sz="750" b="1">
+              <a:rPr sz="1700" b="1">
                 <a:solidFill>
                   <a:srgbClr val="1565C0"/>
                 </a:solidFill>
-                <a:latin typeface="Calibri"/>
+                <a:latin typeface="Fira Sans"/>
               </a:rPr>
               <a:t>● </a:t>
             </a:r>
             <a:r>
-              <a:rPr sz="750" b="1">
+              <a:rPr sz="1700" b="1">
                 <a:solidFill>
                   <a:srgbClr val="1565C0"/>
                 </a:solidFill>
-                <a:latin typeface="Calibri"/>
+                <a:latin typeface="Fira Sans"/>
               </a:rPr>
               <a:t>IN PROGRESS</a:t>
             </a:r>
@@ -5290,8 +5290,8 @@
         </p:nvSpPr>
         <p:spPr>
           <a:xfrm>
-            <a:off x="6313931" y="1956816"/>
-            <a:ext cx="2736341" cy="150875"/>
+            <a:off x="6377940" y="2889504"/>
+            <a:ext cx="2644901" cy="256031"/>
           </a:xfrm>
           <a:prstGeom prst="rect">
             <a:avLst/>
@@ -5305,11 +5305,11 @@
           <a:lstStyle/>
           <a:p>
             <a:r>
-              <a:rPr sz="750" b="0">
+              <a:rPr sz="1700" b="0">
                 <a:solidFill>
                   <a:srgbClr val="3D3D3D"/>
                 </a:solidFill>
-                <a:latin typeface="Calibri"/>
+                <a:latin typeface="Fira Sans"/>
               </a:rPr>
               <a:t>Sub-brand logo override from parent brand</a:t>
             </a:r>
@@ -5324,8 +5324,8 @@
         </p:nvSpPr>
         <p:spPr>
           <a:xfrm>
-            <a:off x="6185916" y="2089404"/>
-            <a:ext cx="2864358" cy="146304"/>
+            <a:off x="6213348" y="3108960"/>
+            <a:ext cx="2809494" cy="237744"/>
           </a:xfrm>
           <a:prstGeom prst="rect">
             <a:avLst/>
@@ -5339,20 +5339,20 @@
           <a:lstStyle/>
           <a:p>
             <a:r>
-              <a:rPr sz="750" b="1">
+              <a:rPr sz="1700" b="1">
                 <a:solidFill>
                   <a:srgbClr val="555555"/>
                 </a:solidFill>
-                <a:latin typeface="Calibri"/>
+                <a:latin typeface="Fira Sans"/>
               </a:rPr>
               <a:t>● </a:t>
             </a:r>
             <a:r>
-              <a:rPr sz="750" b="1">
+              <a:rPr sz="1700" b="1">
                 <a:solidFill>
                   <a:srgbClr val="555555"/>
                 </a:solidFill>
-                <a:latin typeface="Calibri"/>
+                <a:latin typeface="Fira Sans"/>
               </a:rPr>
               <a:t>PLANNED</a:t>
             </a:r>
@@ -5367,8 +5367,8 @@
         </p:nvSpPr>
         <p:spPr>
           <a:xfrm>
-            <a:off x="6313931" y="2235708"/>
-            <a:ext cx="2736341" cy="150875"/>
+            <a:off x="6377940" y="3346704"/>
+            <a:ext cx="2644901" cy="256031"/>
           </a:xfrm>
           <a:prstGeom prst="rect">
             <a:avLst/>
@@ -5382,11 +5382,11 @@
           <a:lstStyle/>
           <a:p>
             <a:r>
-              <a:rPr sz="750" b="0">
+              <a:rPr sz="1700" b="0">
                 <a:solidFill>
                   <a:srgbClr val="3D3D3D"/>
                 </a:solidFill>
-                <a:latin typeface="Calibri"/>
+                <a:latin typeface="Fira Sans"/>
               </a:rPr>
               <a:t>Sub-brand creation workflow bug resolution</a:t>
             </a:r>
@@ -5401,8 +5401,8 @@
         </p:nvSpPr>
         <p:spPr>
           <a:xfrm>
-            <a:off x="6185916" y="2441448"/>
-            <a:ext cx="2864358" cy="173736"/>
+            <a:off x="6213348" y="3694176"/>
+            <a:ext cx="2809494" cy="274320"/>
           </a:xfrm>
           <a:prstGeom prst="rect">
             <a:avLst/>
@@ -5417,11 +5417,11 @@
           <a:p>
             <a:pPr algn="l"/>
             <a:r>
-              <a:rPr sz="850" b="1" i="0">
+              <a:rPr sz="1900" b="1" i="0">
                 <a:solidFill>
                   <a:srgbClr val="1A1A2E"/>
                 </a:solidFill>
-                <a:latin typeface="Calibri"/>
+                <a:latin typeface="Fira Sans"/>
               </a:rPr>
               <a:t>Transition Live Tools → SDK Manager</a:t>
             </a:r>
@@ -5436,8 +5436,8 @@
         </p:nvSpPr>
         <p:spPr>
           <a:xfrm>
-            <a:off x="6185916" y="2615184"/>
-            <a:ext cx="2864358" cy="146304"/>
+            <a:off x="6213348" y="3968496"/>
+            <a:ext cx="2809494" cy="237744"/>
           </a:xfrm>
           <a:prstGeom prst="rect">
             <a:avLst/>
@@ -5451,20 +5451,20 @@
           <a:lstStyle/>
           <a:p>
             <a:r>
-              <a:rPr sz="750" b="1">
+              <a:rPr sz="1700" b="1">
                 <a:solidFill>
                   <a:srgbClr val="1565C0"/>
                 </a:solidFill>
-                <a:latin typeface="Calibri"/>
+                <a:latin typeface="Fira Sans"/>
               </a:rPr>
               <a:t>● </a:t>
             </a:r>
             <a:r>
-              <a:rPr sz="750" b="1">
+              <a:rPr sz="1700" b="1">
                 <a:solidFill>
                   <a:srgbClr val="1565C0"/>
                 </a:solidFill>
-                <a:latin typeface="Calibri"/>
+                <a:latin typeface="Fira Sans"/>
               </a:rPr>
               <a:t>IN PROGRESS</a:t>
             </a:r>
@@ -5479,8 +5479,8 @@
         </p:nvSpPr>
         <p:spPr>
           <a:xfrm>
-            <a:off x="6313931" y="2761488"/>
-            <a:ext cx="2736341" cy="150875"/>
+            <a:off x="6377940" y="4206240"/>
+            <a:ext cx="2644901" cy="256031"/>
           </a:xfrm>
           <a:prstGeom prst="rect">
             <a:avLst/>
@@ -5494,11 +5494,11 @@
           <a:lstStyle/>
           <a:p>
             <a:r>
-              <a:rPr sz="750" b="0">
+              <a:rPr sz="1700" b="0">
                 <a:solidFill>
                   <a:srgbClr val="3D3D3D"/>
                 </a:solidFill>
-                <a:latin typeface="Calibri"/>
+                <a:latin typeface="Fira Sans"/>
               </a:rPr>
               <a:t>Onboarding 7 live tools to SDK Manager with Config IDs</a:t>
             </a:r>
@@ -5513,8 +5513,8 @@
         </p:nvSpPr>
         <p:spPr>
           <a:xfrm>
-            <a:off x="6313931" y="2894076"/>
-            <a:ext cx="2736341" cy="150875"/>
+            <a:off x="6377940" y="4425696"/>
+            <a:ext cx="2644901" cy="402336"/>
           </a:xfrm>
           <a:prstGeom prst="rect">
             <a:avLst/>
@@ -5528,11 +5528,11 @@
           <a:lstStyle/>
           <a:p>
             <a:r>
-              <a:rPr sz="750" b="0">
+              <a:rPr sz="1700" b="0">
                 <a:solidFill>
                   <a:srgbClr val="3D3D3D"/>
                 </a:solidFill>
-                <a:latin typeface="Calibri"/>
+                <a:latin typeface="Fira Sans"/>
               </a:rPr>
               <a:t>(PWC, KWC, ToothCheck, ToothScan, PoopScan, Dermascan, Pawscan)</a:t>
             </a:r>
@@ -5547,8 +5547,8 @@
         </p:nvSpPr>
         <p:spPr>
           <a:xfrm>
-            <a:off x="9141714" y="658368"/>
-            <a:ext cx="10972" cy="5925312"/>
+            <a:off x="9141714" y="749808"/>
+            <a:ext cx="10972" cy="5788152"/>
           </a:xfrm>
           <a:prstGeom prst="rect">
             <a:avLst/>
@@ -5590,8 +5590,8 @@
         </p:nvSpPr>
         <p:spPr>
           <a:xfrm>
-            <a:off x="9233154" y="749808"/>
-            <a:ext cx="2864358" cy="22860"/>
+            <a:off x="9260586" y="859536"/>
+            <a:ext cx="2809494" cy="27432"/>
           </a:xfrm>
           <a:prstGeom prst="rect">
             <a:avLst/>
@@ -5633,8 +5633,8 @@
         </p:nvSpPr>
         <p:spPr>
           <a:xfrm>
-            <a:off x="9233154" y="777240"/>
-            <a:ext cx="2864358" cy="182880"/>
+            <a:off x="9260586" y="896112"/>
+            <a:ext cx="2809494" cy="310896"/>
           </a:xfrm>
           <a:prstGeom prst="rect">
             <a:avLst/>
@@ -5649,11 +5649,11 @@
           <a:p>
             <a:pPr algn="l"/>
             <a:r>
-              <a:rPr sz="800" b="1" i="0">
+              <a:rPr sz="2200" b="1" i="0">
                 <a:solidFill>
                   <a:srgbClr val="1B2A4A"/>
                 </a:solidFill>
-                <a:latin typeface="Calibri"/>
+                <a:latin typeface="Fira Sans"/>
               </a:rPr>
               <a:t>SDK – VERSION WORKFLOW</a:t>
             </a:r>
@@ -5668,8 +5668,8 @@
         </p:nvSpPr>
         <p:spPr>
           <a:xfrm>
-            <a:off x="9233154" y="960120"/>
-            <a:ext cx="2864358" cy="7315"/>
+            <a:off x="9260586" y="1207008"/>
+            <a:ext cx="2809494" cy="9144"/>
           </a:xfrm>
           <a:prstGeom prst="rect">
             <a:avLst/>
@@ -5711,8 +5711,8 @@
         </p:nvSpPr>
         <p:spPr>
           <a:xfrm>
-            <a:off x="9233154" y="978408"/>
-            <a:ext cx="2864358" cy="173736"/>
+            <a:off x="9260586" y="1298448"/>
+            <a:ext cx="2809494" cy="274320"/>
           </a:xfrm>
           <a:prstGeom prst="rect">
             <a:avLst/>
@@ -5727,11 +5727,11 @@
           <a:p>
             <a:pPr algn="l"/>
             <a:r>
-              <a:rPr sz="850" b="1" i="0">
+              <a:rPr sz="1900" b="1" i="0">
                 <a:solidFill>
                   <a:srgbClr val="1A1A2E"/>
                 </a:solidFill>
-                <a:latin typeface="Calibri"/>
+                <a:latin typeface="Fira Sans"/>
               </a:rPr>
               <a:t>SDK Version Workflow Enhancements</a:t>
             </a:r>
@@ -5746,8 +5746,8 @@
         </p:nvSpPr>
         <p:spPr>
           <a:xfrm>
-            <a:off x="9233154" y="1152144"/>
-            <a:ext cx="2864358" cy="146304"/>
+            <a:off x="9260586" y="1572768"/>
+            <a:ext cx="2809494" cy="237744"/>
           </a:xfrm>
           <a:prstGeom prst="rect">
             <a:avLst/>
@@ -5761,20 +5761,20 @@
           <a:lstStyle/>
           <a:p>
             <a:r>
-              <a:rPr sz="750" b="1">
+              <a:rPr sz="1700" b="1">
                 <a:solidFill>
                   <a:srgbClr val="1565C0"/>
                 </a:solidFill>
-                <a:latin typeface="Calibri"/>
+                <a:latin typeface="Fira Sans"/>
               </a:rPr>
               <a:t>● </a:t>
             </a:r>
             <a:r>
-              <a:rPr sz="750" b="1">
+              <a:rPr sz="1700" b="1">
                 <a:solidFill>
                   <a:srgbClr val="1565C0"/>
                 </a:solidFill>
-                <a:latin typeface="Calibri"/>
+                <a:latin typeface="Fira Sans"/>
               </a:rPr>
               <a:t>IN PROGRESS</a:t>
             </a:r>
@@ -5789,8 +5789,8 @@
         </p:nvSpPr>
         <p:spPr>
           <a:xfrm>
-            <a:off x="9361170" y="1298448"/>
-            <a:ext cx="2736341" cy="150875"/>
+            <a:off x="9425178" y="1810512"/>
+            <a:ext cx="2644901" cy="402336"/>
           </a:xfrm>
           <a:prstGeom prst="rect">
             <a:avLst/>
@@ -5804,11 +5804,11 @@
           <a:lstStyle/>
           <a:p>
             <a:r>
-              <a:rPr sz="750" b="0">
+              <a:rPr sz="1700" b="0">
                 <a:solidFill>
                   <a:srgbClr val="3D3D3D"/>
                 </a:solidFill>
-                <a:latin typeface="Calibri"/>
+                <a:latin typeface="Fira Sans"/>
               </a:rPr>
               <a:t>Save/Delete/Lifecycle consistency design for Versions &amp; Variants</a:t>
             </a:r>
@@ -5823,8 +5823,8 @@
         </p:nvSpPr>
         <p:spPr>
           <a:xfrm>
-            <a:off x="9361170" y="1431036"/>
-            <a:ext cx="2736341" cy="150875"/>
+            <a:off x="9425178" y="2176272"/>
+            <a:ext cx="2644901" cy="256031"/>
           </a:xfrm>
           <a:prstGeom prst="rect">
             <a:avLst/>
@@ -5838,11 +5838,11 @@
           <a:lstStyle/>
           <a:p>
             <a:r>
-              <a:rPr sz="750" b="0">
+              <a:rPr sz="1700" b="0">
                 <a:solidFill>
                   <a:srgbClr val="3D3D3D"/>
                 </a:solidFill>
-                <a:latin typeface="Calibri"/>
+                <a:latin typeface="Fira Sans"/>
               </a:rPr>
               <a:t>Safe &amp; consistent lifecycle implementation (FE &amp; BE)</a:t>
             </a:r>
@@ -5857,8 +5857,8 @@
         </p:nvSpPr>
         <p:spPr>
           <a:xfrm>
-            <a:off x="9233154" y="1636776"/>
-            <a:ext cx="2864358" cy="173736"/>
+            <a:off x="9260586" y="2523744"/>
+            <a:ext cx="2809494" cy="274320"/>
           </a:xfrm>
           <a:prstGeom prst="rect">
             <a:avLst/>
@@ -5873,11 +5873,11 @@
           <a:p>
             <a:pPr algn="l"/>
             <a:r>
-              <a:rPr sz="850" b="1" i="0">
+              <a:rPr sz="1900" b="1" i="0">
                 <a:solidFill>
                   <a:srgbClr val="1A1A2E"/>
                 </a:solidFill>
-                <a:latin typeface="Calibri"/>
+                <a:latin typeface="Fira Sans"/>
               </a:rPr>
               <a:t>Template Creation from SDK Version</a:t>
             </a:r>
@@ -5892,8 +5892,8 @@
         </p:nvSpPr>
         <p:spPr>
           <a:xfrm>
-            <a:off x="9233154" y="1810512"/>
-            <a:ext cx="2864358" cy="146304"/>
+            <a:off x="9260586" y="2798064"/>
+            <a:ext cx="2809494" cy="237744"/>
           </a:xfrm>
           <a:prstGeom prst="rect">
             <a:avLst/>
@@ -5907,20 +5907,20 @@
           <a:lstStyle/>
           <a:p>
             <a:r>
-              <a:rPr sz="750" b="1">
+              <a:rPr sz="1700" b="1">
                 <a:solidFill>
                   <a:srgbClr val="555555"/>
                 </a:solidFill>
-                <a:latin typeface="Calibri"/>
+                <a:latin typeface="Fira Sans"/>
               </a:rPr>
               <a:t>● </a:t>
             </a:r>
             <a:r>
-              <a:rPr sz="750" b="1">
+              <a:rPr sz="1700" b="1">
                 <a:solidFill>
                   <a:srgbClr val="555555"/>
                 </a:solidFill>
-                <a:latin typeface="Calibri"/>
+                <a:latin typeface="Fira Sans"/>
               </a:rPr>
               <a:t>PLANNED</a:t>
             </a:r>
@@ -5935,8 +5935,8 @@
         </p:nvSpPr>
         <p:spPr>
           <a:xfrm>
-            <a:off x="9361170" y="1956816"/>
-            <a:ext cx="2736341" cy="150875"/>
+            <a:off x="9425178" y="3035808"/>
+            <a:ext cx="2644901" cy="402336"/>
           </a:xfrm>
           <a:prstGeom prst="rect">
             <a:avLst/>
@@ -5950,11 +5950,11 @@
           <a:lstStyle/>
           <a:p>
             <a:r>
-              <a:rPr sz="750" b="0">
+              <a:rPr sz="1700" b="0">
                 <a:solidFill>
                   <a:srgbClr val="3D3D3D"/>
                 </a:solidFill>
-                <a:latin typeface="Calibri"/>
+                <a:latin typeface="Fira Sans"/>
               </a:rPr>
               <a:t>Template creation from existing SDK Version in SDK Manager</a:t>
             </a:r>
@@ -5969,8 +5969,8 @@
         </p:nvSpPr>
         <p:spPr>
           <a:xfrm>
-            <a:off x="9233154" y="2162556"/>
-            <a:ext cx="2864358" cy="173736"/>
+            <a:off x="9260586" y="3529584"/>
+            <a:ext cx="2809494" cy="274320"/>
           </a:xfrm>
           <a:prstGeom prst="rect">
             <a:avLst/>
@@ -5985,11 +5985,11 @@
           <a:p>
             <a:pPr algn="l"/>
             <a:r>
-              <a:rPr sz="850" b="1" i="0">
+              <a:rPr sz="1900" b="1" i="0">
                 <a:solidFill>
                   <a:srgbClr val="1A1A2E"/>
                 </a:solidFill>
-                <a:latin typeface="Calibri"/>
+                <a:latin typeface="Fira Sans"/>
               </a:rPr>
               <a:t>Platform Stability &amp; Modernization</a:t>
             </a:r>
@@ -6004,8 +6004,8 @@
         </p:nvSpPr>
         <p:spPr>
           <a:xfrm>
-            <a:off x="9233154" y="2336292"/>
-            <a:ext cx="2864358" cy="146304"/>
+            <a:off x="9260586" y="3803904"/>
+            <a:ext cx="2809494" cy="237744"/>
           </a:xfrm>
           <a:prstGeom prst="rect">
             <a:avLst/>
@@ -6019,20 +6019,20 @@
           <a:lstStyle/>
           <a:p>
             <a:r>
-              <a:rPr sz="750" b="1">
+              <a:rPr sz="1700" b="1">
                 <a:solidFill>
                   <a:srgbClr val="555555"/>
                 </a:solidFill>
-                <a:latin typeface="Calibri"/>
+                <a:latin typeface="Fira Sans"/>
               </a:rPr>
               <a:t>● </a:t>
             </a:r>
             <a:r>
-              <a:rPr sz="750" b="1">
+              <a:rPr sz="1700" b="1">
                 <a:solidFill>
                   <a:srgbClr val="555555"/>
                 </a:solidFill>
-                <a:latin typeface="Calibri"/>
+                <a:latin typeface="Fira Sans"/>
               </a:rPr>
               <a:t>PLANNED</a:t>
             </a:r>
@@ -6047,8 +6047,8 @@
         </p:nvSpPr>
         <p:spPr>
           <a:xfrm>
-            <a:off x="9361170" y="2482596"/>
-            <a:ext cx="2736341" cy="150875"/>
+            <a:off x="9425178" y="4041648"/>
+            <a:ext cx="2644901" cy="256031"/>
           </a:xfrm>
           <a:prstGeom prst="rect">
             <a:avLst/>
@@ -6062,11 +6062,11 @@
           <a:lstStyle/>
           <a:p>
             <a:r>
-              <a:rPr sz="750" b="0">
+              <a:rPr sz="1700" b="0">
                 <a:solidFill>
                   <a:srgbClr val="3D3D3D"/>
                 </a:solidFill>
-                <a:latin typeface="Calibri"/>
+                <a:latin typeface="Fira Sans"/>
               </a:rPr>
               <a:t>Reusable large text content component for D&amp;D builder</a:t>
             </a:r>
@@ -6081,8 +6081,8 @@
         </p:nvSpPr>
         <p:spPr>
           <a:xfrm>
-            <a:off x="9361170" y="2615184"/>
-            <a:ext cx="2736341" cy="150875"/>
+            <a:off x="9425178" y="4261104"/>
+            <a:ext cx="2644901" cy="256031"/>
           </a:xfrm>
           <a:prstGeom prst="rect">
             <a:avLst/>
@@ -6096,11 +6096,11 @@
           <a:lstStyle/>
           <a:p>
             <a:r>
-              <a:rPr sz="750" b="0">
+              <a:rPr sz="1700" b="0">
                 <a:solidFill>
                   <a:srgbClr val="3D3D3D"/>
                 </a:solidFill>
-                <a:latin typeface="Calibri"/>
+                <a:latin typeface="Fira Sans"/>
               </a:rPr>
               <a:t>SDK Version Template listing by species &amp; tool</a:t>
             </a:r>
@@ -6134,7 +6134,7 @@
         <p:spPr>
           <a:xfrm>
             <a:off x="0" y="0"/>
-            <a:ext cx="12188952" cy="658368"/>
+            <a:ext cx="12188952" cy="749808"/>
           </a:xfrm>
           <a:prstGeom prst="rect">
             <a:avLst/>
@@ -6177,7 +6177,7 @@
         <p:spPr>
           <a:xfrm>
             <a:off x="0" y="0"/>
-            <a:ext cx="64008" cy="658368"/>
+            <a:ext cx="82296" cy="749808"/>
           </a:xfrm>
           <a:prstGeom prst="rect">
             <a:avLst/>
@@ -6219,8 +6219,8 @@
         </p:nvSpPr>
         <p:spPr>
           <a:xfrm>
-            <a:off x="164592" y="54864"/>
-            <a:ext cx="8686800" cy="274320"/>
+            <a:off x="201168" y="64008"/>
+            <a:ext cx="8686800" cy="347472"/>
           </a:xfrm>
           <a:prstGeom prst="rect">
             <a:avLst/>
@@ -6235,11 +6235,11 @@
           <a:p>
             <a:pPr algn="l"/>
             <a:r>
-              <a:rPr sz="1300" b="1" i="0">
+              <a:rPr sz="2000" b="1" i="0">
                 <a:solidFill>
                   <a:srgbClr val="FFFFFF"/>
                 </a:solidFill>
-                <a:latin typeface="Calibri"/>
+                <a:latin typeface="Fira Sans"/>
               </a:rPr>
               <a:t>Executive Summary – GD Core Team   Project Health:</a:t>
             </a:r>
@@ -6254,8 +6254,8 @@
         </p:nvSpPr>
         <p:spPr>
           <a:xfrm>
-            <a:off x="164592" y="338328"/>
-            <a:ext cx="6858000" cy="201168"/>
+            <a:off x="201168" y="420624"/>
+            <a:ext cx="7315200" cy="237744"/>
           </a:xfrm>
           <a:prstGeom prst="rect">
             <a:avLst/>
@@ -6270,11 +6270,11 @@
           <a:p>
             <a:pPr algn="l"/>
             <a:r>
-              <a:rPr sz="800" b="0" i="0">
+              <a:rPr sz="1300" b="0" i="0">
                 <a:solidFill>
                   <a:srgbClr val="BBDEFB"/>
                 </a:solidFill>
-                <a:latin typeface="Calibri"/>
+                <a:latin typeface="Fira Sans"/>
               </a:rPr>
               <a:t>Mars – Digital Health Transformation  ·  Sprint 48 · Jun 23 – Jul 6, 2026</a:t>
             </a:r>
@@ -6289,8 +6289,8 @@
         </p:nvSpPr>
         <p:spPr>
           <a:xfrm>
-            <a:off x="8961120" y="73152"/>
-            <a:ext cx="3063240" cy="201168"/>
+            <a:off x="8961120" y="91440"/>
+            <a:ext cx="3063240" cy="256032"/>
           </a:xfrm>
           <a:prstGeom prst="rect">
             <a:avLst/>
@@ -6305,11 +6305,11 @@
           <a:p>
             <a:pPr algn="r"/>
             <a:r>
-              <a:rPr sz="900" b="0" i="0">
+              <a:rPr sz="1400" b="0" i="0">
                 <a:solidFill>
                   <a:srgbClr val="FFFFFF"/>
                 </a:solidFill>
-                <a:latin typeface="Calibri"/>
+                <a:latin typeface="Fira Sans"/>
               </a:rPr>
               <a:t>www.griddynamics.com</a:t>
             </a:r>
@@ -6324,8 +6324,8 @@
         </p:nvSpPr>
         <p:spPr>
           <a:xfrm>
-            <a:off x="8961120" y="274320"/>
-            <a:ext cx="3063240" cy="201168"/>
+            <a:off x="8961120" y="365760"/>
+            <a:ext cx="3063240" cy="237744"/>
           </a:xfrm>
           <a:prstGeom prst="rect">
             <a:avLst/>
@@ -6340,11 +6340,11 @@
           <a:p>
             <a:pPr algn="r"/>
             <a:r>
-              <a:rPr sz="650" b="0" i="1">
+              <a:rPr sz="1000" b="0" i="1">
                 <a:solidFill>
                   <a:srgbClr val="BBDEFB"/>
                 </a:solidFill>
-                <a:latin typeface="Calibri"/>
+                <a:latin typeface="Fira Sans"/>
               </a:rPr>
               <a:t>trusted engineering partner for digital transformation</a:t>
             </a:r>
@@ -6359,8 +6359,8 @@
         </p:nvSpPr>
         <p:spPr>
           <a:xfrm>
-            <a:off x="11430000" y="173736"/>
-            <a:ext cx="384048" cy="274320"/>
+            <a:off x="11704320" y="201168"/>
+            <a:ext cx="365760" cy="292608"/>
           </a:xfrm>
           <a:prstGeom prst="rect">
             <a:avLst/>
@@ -6402,8 +6402,8 @@
         </p:nvSpPr>
         <p:spPr>
           <a:xfrm>
-            <a:off x="11430000" y="173736"/>
-            <a:ext cx="384048" cy="274320"/>
+            <a:off x="11704320" y="201168"/>
+            <a:ext cx="365760" cy="292608"/>
           </a:xfrm>
           <a:prstGeom prst="rect">
             <a:avLst/>
@@ -6418,11 +6418,11 @@
           <a:p>
             <a:pPr algn="ctr"/>
             <a:r>
-              <a:rPr sz="900" b="1" i="0">
+              <a:rPr sz="1400" b="1" i="0">
                 <a:solidFill>
                   <a:srgbClr val="FFFFFF"/>
                 </a:solidFill>
-                <a:latin typeface="Calibri"/>
+                <a:latin typeface="Fira Sans"/>
               </a:rPr>
               <a:t>4</a:t>
             </a:r>
@@ -6437,8 +6437,8 @@
         </p:nvSpPr>
         <p:spPr>
           <a:xfrm>
-            <a:off x="0" y="6583680"/>
-            <a:ext cx="12188952" cy="274320"/>
+            <a:off x="0" y="6537960"/>
+            <a:ext cx="12188952" cy="320040"/>
           </a:xfrm>
           <a:prstGeom prst="rect">
             <a:avLst/>
@@ -6480,8 +6480,8 @@
         </p:nvSpPr>
         <p:spPr>
           <a:xfrm>
-            <a:off x="0" y="6583680"/>
-            <a:ext cx="64008" cy="274320"/>
+            <a:off x="0" y="6537960"/>
+            <a:ext cx="82296" cy="320040"/>
           </a:xfrm>
           <a:prstGeom prst="rect">
             <a:avLst/>
@@ -6523,8 +6523,8 @@
         </p:nvSpPr>
         <p:spPr>
           <a:xfrm>
-            <a:off x="164592" y="6629400"/>
-            <a:ext cx="7772400" cy="201168"/>
+            <a:off x="201168" y="6601968"/>
+            <a:ext cx="7772400" cy="219456"/>
           </a:xfrm>
           <a:prstGeom prst="rect">
             <a:avLst/>
@@ -6539,11 +6539,11 @@
           <a:p>
             <a:pPr algn="l"/>
             <a:r>
-              <a:rPr sz="700" b="0" i="0">
+              <a:rPr sz="1100" b="0" i="0">
                 <a:solidFill>
                   <a:srgbClr val="BBDEFB"/>
                 </a:solidFill>
-                <a:latin typeface="Calibri"/>
+                <a:latin typeface="Fira Sans"/>
               </a:rPr>
               <a:t>Grid Dynamics / Mars – Digital Health Transformation / WSR – June 29, 2026</a:t>
             </a:r>
@@ -6558,8 +6558,8 @@
         </p:nvSpPr>
         <p:spPr>
           <a:xfrm>
-            <a:off x="8686800" y="6629400"/>
-            <a:ext cx="3337560" cy="201168"/>
+            <a:off x="8686800" y="6601968"/>
+            <a:ext cx="3337560" cy="219456"/>
           </a:xfrm>
           <a:prstGeom prst="rect">
             <a:avLst/>
@@ -6574,11 +6574,11 @@
           <a:p>
             <a:pPr algn="r"/>
             <a:r>
-              <a:rPr sz="700" b="0" i="0">
+              <a:rPr sz="1100" b="0" i="0">
                 <a:solidFill>
                   <a:srgbClr val="BBDEFB"/>
                 </a:solidFill>
-                <a:latin typeface="Calibri"/>
+                <a:latin typeface="Fira Sans"/>
               </a:rPr>
               <a:t>Privileged and confidential</a:t>
             </a:r>
@@ -6593,8 +6593,8 @@
         </p:nvSpPr>
         <p:spPr>
           <a:xfrm>
-            <a:off x="0" y="658368"/>
-            <a:ext cx="12188952" cy="5925312"/>
+            <a:off x="0" y="749808"/>
+            <a:ext cx="12188952" cy="5788152"/>
           </a:xfrm>
           <a:prstGeom prst="rect">
             <a:avLst/>
@@ -6636,8 +6636,8 @@
         </p:nvSpPr>
         <p:spPr>
           <a:xfrm>
-            <a:off x="91440" y="749808"/>
-            <a:ext cx="2864358" cy="22860"/>
+            <a:off x="118872" y="859536"/>
+            <a:ext cx="2809494" cy="27432"/>
           </a:xfrm>
           <a:prstGeom prst="rect">
             <a:avLst/>
@@ -6679,8 +6679,8 @@
         </p:nvSpPr>
         <p:spPr>
           <a:xfrm>
-            <a:off x="91440" y="777240"/>
-            <a:ext cx="2864358" cy="182880"/>
+            <a:off x="118872" y="896112"/>
+            <a:ext cx="2809494" cy="310896"/>
           </a:xfrm>
           <a:prstGeom prst="rect">
             <a:avLst/>
@@ -6695,11 +6695,11 @@
           <a:p>
             <a:pPr algn="l"/>
             <a:r>
-              <a:rPr sz="800" b="1" i="0">
+              <a:rPr sz="2200" b="1" i="0">
                 <a:solidFill>
                   <a:srgbClr val="1B2A4A"/>
                 </a:solidFill>
-                <a:latin typeface="Calibri"/>
+                <a:latin typeface="Fira Sans"/>
               </a:rPr>
               <a:t>FEEDBACK CAPTURE</a:t>
             </a:r>
@@ -6714,8 +6714,8 @@
         </p:nvSpPr>
         <p:spPr>
           <a:xfrm>
-            <a:off x="91440" y="960120"/>
-            <a:ext cx="2864358" cy="7315"/>
+            <a:off x="118872" y="1207008"/>
+            <a:ext cx="2809494" cy="9144"/>
           </a:xfrm>
           <a:prstGeom prst="rect">
             <a:avLst/>
@@ -6757,8 +6757,8 @@
         </p:nvSpPr>
         <p:spPr>
           <a:xfrm>
-            <a:off x="91440" y="978408"/>
-            <a:ext cx="2864358" cy="173736"/>
+            <a:off x="118872" y="1298448"/>
+            <a:ext cx="2809494" cy="274320"/>
           </a:xfrm>
           <a:prstGeom prst="rect">
             <a:avLst/>
@@ -6773,11 +6773,11 @@
           <a:p>
             <a:pPr algn="l"/>
             <a:r>
-              <a:rPr sz="850" b="1" i="0">
+              <a:rPr sz="1900" b="1" i="0">
                 <a:solidFill>
                   <a:srgbClr val="1A1A2E"/>
                 </a:solidFill>
-                <a:latin typeface="Calibri"/>
+                <a:latin typeface="Fira Sans"/>
               </a:rPr>
               <a:t>Feedback Capture – All Tools</a:t>
             </a:r>
@@ -6792,8 +6792,8 @@
         </p:nvSpPr>
         <p:spPr>
           <a:xfrm>
-            <a:off x="91440" y="1152144"/>
-            <a:ext cx="2864358" cy="146304"/>
+            <a:off x="118872" y="1572768"/>
+            <a:ext cx="2809494" cy="237744"/>
           </a:xfrm>
           <a:prstGeom prst="rect">
             <a:avLst/>
@@ -6807,20 +6807,20 @@
           <a:lstStyle/>
           <a:p>
             <a:r>
-              <a:rPr sz="750" b="1">
+              <a:rPr sz="1700" b="1">
                 <a:solidFill>
                   <a:srgbClr val="1565C0"/>
                 </a:solidFill>
-                <a:latin typeface="Calibri"/>
+                <a:latin typeface="Fira Sans"/>
               </a:rPr>
               <a:t>● </a:t>
             </a:r>
             <a:r>
-              <a:rPr sz="750" b="1">
+              <a:rPr sz="1700" b="1">
                 <a:solidFill>
                   <a:srgbClr val="1565C0"/>
                 </a:solidFill>
-                <a:latin typeface="Calibri"/>
+                <a:latin typeface="Fira Sans"/>
               </a:rPr>
               <a:t>IN PROGRESS</a:t>
             </a:r>
@@ -6835,8 +6835,8 @@
         </p:nvSpPr>
         <p:spPr>
           <a:xfrm>
-            <a:off x="219456" y="1298448"/>
-            <a:ext cx="2736341" cy="150875"/>
+            <a:off x="283464" y="1810512"/>
+            <a:ext cx="2644901" cy="256031"/>
           </a:xfrm>
           <a:prstGeom prst="rect">
             <a:avLst/>
@@ -6850,11 +6850,11 @@
           <a:lstStyle/>
           <a:p>
             <a:r>
-              <a:rPr sz="750" b="0">
+              <a:rPr sz="1700" b="0">
                 <a:solidFill>
                   <a:srgbClr val="3D3D3D"/>
                 </a:solidFill>
-                <a:latin typeface="Calibri"/>
+                <a:latin typeface="Fira Sans"/>
               </a:rPr>
               <a:t>Feedback submission API backend implementation</a:t>
             </a:r>
@@ -6869,8 +6869,8 @@
         </p:nvSpPr>
         <p:spPr>
           <a:xfrm>
-            <a:off x="91440" y="1431036"/>
-            <a:ext cx="2864358" cy="146304"/>
+            <a:off x="118872" y="2029968"/>
+            <a:ext cx="2809494" cy="237744"/>
           </a:xfrm>
           <a:prstGeom prst="rect">
             <a:avLst/>
@@ -6884,20 +6884,20 @@
           <a:lstStyle/>
           <a:p>
             <a:r>
-              <a:rPr sz="750" b="1">
+              <a:rPr sz="1700" b="1">
                 <a:solidFill>
                   <a:srgbClr val="555555"/>
                 </a:solidFill>
-                <a:latin typeface="Calibri"/>
+                <a:latin typeface="Fira Sans"/>
               </a:rPr>
               <a:t>● </a:t>
             </a:r>
             <a:r>
-              <a:rPr sz="750" b="1">
+              <a:rPr sz="1700" b="1">
                 <a:solidFill>
                   <a:srgbClr val="555555"/>
                 </a:solidFill>
-                <a:latin typeface="Calibri"/>
+                <a:latin typeface="Fira Sans"/>
               </a:rPr>
               <a:t>PLANNED</a:t>
             </a:r>
@@ -6912,8 +6912,8 @@
         </p:nvSpPr>
         <p:spPr>
           <a:xfrm>
-            <a:off x="219456" y="1577339"/>
-            <a:ext cx="2736341" cy="150875"/>
+            <a:off x="283464" y="2267712"/>
+            <a:ext cx="2644901" cy="256031"/>
           </a:xfrm>
           <a:prstGeom prst="rect">
             <a:avLst/>
@@ -6927,11 +6927,11 @@
           <a:lstStyle/>
           <a:p>
             <a:r>
-              <a:rPr sz="750" b="0">
+              <a:rPr sz="1700" b="0">
                 <a:solidFill>
                   <a:srgbClr val="3D3D3D"/>
                 </a:solidFill>
-                <a:latin typeface="Calibri"/>
+                <a:latin typeface="Fira Sans"/>
               </a:rPr>
               <a:t>Feedback Form frontend component (D&amp;D, Macro, Preview)</a:t>
             </a:r>
@@ -6946,8 +6946,8 @@
         </p:nvSpPr>
         <p:spPr>
           <a:xfrm>
-            <a:off x="219456" y="1709928"/>
-            <a:ext cx="2736341" cy="150875"/>
+            <a:off x="283464" y="2487168"/>
+            <a:ext cx="2644901" cy="256031"/>
           </a:xfrm>
           <a:prstGeom prst="rect">
             <a:avLst/>
@@ -6961,11 +6961,11 @@
           <a:lstStyle/>
           <a:p>
             <a:r>
-              <a:rPr sz="750" b="0">
+              <a:rPr sz="1700" b="0">
                 <a:solidFill>
                   <a:srgbClr val="3D3D3D"/>
                 </a:solidFill>
-                <a:latin typeface="Calibri"/>
+                <a:latin typeface="Fira Sans"/>
               </a:rPr>
               <a:t>Feedback Form API integration in SDK</a:t>
             </a:r>
@@ -6980,8 +6980,8 @@
         </p:nvSpPr>
         <p:spPr>
           <a:xfrm>
-            <a:off x="219456" y="1842515"/>
-            <a:ext cx="2736341" cy="150875"/>
+            <a:off x="283464" y="2706624"/>
+            <a:ext cx="2644901" cy="256031"/>
           </a:xfrm>
           <a:prstGeom prst="rect">
             <a:avLst/>
@@ -6995,11 +6995,11 @@
           <a:lstStyle/>
           <a:p>
             <a:r>
-              <a:rPr sz="750" b="0">
+              <a:rPr sz="1700" b="0">
                 <a:solidFill>
                   <a:srgbClr val="3D3D3D"/>
                 </a:solidFill>
-                <a:latin typeface="Calibri"/>
+                <a:latin typeface="Fira Sans"/>
               </a:rPr>
               <a:t>Feedback analytics integration</a:t>
             </a:r>
@@ -7014,8 +7014,8 @@
         </p:nvSpPr>
         <p:spPr>
           <a:xfrm>
-            <a:off x="219456" y="1975103"/>
-            <a:ext cx="2736341" cy="150875"/>
+            <a:off x="283464" y="2926080"/>
+            <a:ext cx="2644901" cy="256031"/>
           </a:xfrm>
           <a:prstGeom prst="rect">
             <a:avLst/>
@@ -7029,11 +7029,11 @@
           <a:lstStyle/>
           <a:p>
             <a:r>
-              <a:rPr sz="750" b="0">
+              <a:rPr sz="1700" b="0">
                 <a:solidFill>
                   <a:srgbClr val="3D3D3D"/>
                 </a:solidFill>
-                <a:latin typeface="Calibri"/>
+                <a:latin typeface="Fira Sans"/>
               </a:rPr>
               <a:t>Feedback form frequency &amp; TTL settings in SDK Manager</a:t>
             </a:r>
@@ -7048,8 +7048,8 @@
         </p:nvSpPr>
         <p:spPr>
           <a:xfrm>
-            <a:off x="3047238" y="658368"/>
-            <a:ext cx="10972" cy="5925312"/>
+            <a:off x="3047238" y="749808"/>
+            <a:ext cx="10972" cy="5788152"/>
           </a:xfrm>
           <a:prstGeom prst="rect">
             <a:avLst/>
@@ -7091,8 +7091,8 @@
         </p:nvSpPr>
         <p:spPr>
           <a:xfrm>
-            <a:off x="3138678" y="749808"/>
-            <a:ext cx="2864358" cy="22860"/>
+            <a:off x="3166110" y="859536"/>
+            <a:ext cx="2809494" cy="27432"/>
           </a:xfrm>
           <a:prstGeom prst="rect">
             <a:avLst/>
@@ -7134,8 +7134,8 @@
         </p:nvSpPr>
         <p:spPr>
           <a:xfrm>
-            <a:off x="3138678" y="777240"/>
-            <a:ext cx="2864358" cy="182880"/>
+            <a:off x="3166110" y="896112"/>
+            <a:ext cx="2809494" cy="310896"/>
           </a:xfrm>
           <a:prstGeom prst="rect">
             <a:avLst/>
@@ -7150,11 +7150,11 @@
           <a:p>
             <a:pPr algn="l"/>
             <a:r>
-              <a:rPr sz="800" b="1" i="0">
+              <a:rPr sz="2200" b="1" i="0">
                 <a:solidFill>
                   <a:srgbClr val="1B2A4A"/>
                 </a:solidFill>
-                <a:latin typeface="Calibri"/>
+                <a:latin typeface="Fira Sans"/>
               </a:rPr>
               <a:t>BACKEND – INFRA &amp; MIGRATION</a:t>
             </a:r>
@@ -7169,8 +7169,8 @@
         </p:nvSpPr>
         <p:spPr>
           <a:xfrm>
-            <a:off x="3138678" y="960120"/>
-            <a:ext cx="2864358" cy="7315"/>
+            <a:off x="3166110" y="1207008"/>
+            <a:ext cx="2809494" cy="9144"/>
           </a:xfrm>
           <a:prstGeom prst="rect">
             <a:avLst/>
@@ -7212,8 +7212,8 @@
         </p:nvSpPr>
         <p:spPr>
           <a:xfrm>
-            <a:off x="3138678" y="978408"/>
-            <a:ext cx="2864358" cy="173736"/>
+            <a:off x="3166110" y="1298448"/>
+            <a:ext cx="2809494" cy="274320"/>
           </a:xfrm>
           <a:prstGeom prst="rect">
             <a:avLst/>
@@ -7228,11 +7228,11 @@
           <a:p>
             <a:pPr algn="l"/>
             <a:r>
-              <a:rPr sz="850" b="1" i="0">
+              <a:rPr sz="1900" b="1" i="0">
                 <a:solidFill>
                   <a:srgbClr val="1A1A2E"/>
                 </a:solidFill>
-                <a:latin typeface="Calibri"/>
+                <a:latin typeface="Fira Sans"/>
               </a:rPr>
               <a:t>Monorepo Migration – Backend Services</a:t>
             </a:r>
@@ -7247,8 +7247,8 @@
         </p:nvSpPr>
         <p:spPr>
           <a:xfrm>
-            <a:off x="3138678" y="1152144"/>
-            <a:ext cx="2864358" cy="146304"/>
+            <a:off x="3166110" y="1572768"/>
+            <a:ext cx="2809494" cy="237744"/>
           </a:xfrm>
           <a:prstGeom prst="rect">
             <a:avLst/>
@@ -7262,20 +7262,20 @@
           <a:lstStyle/>
           <a:p>
             <a:r>
-              <a:rPr sz="750" b="1">
+              <a:rPr sz="1700" b="1">
                 <a:solidFill>
                   <a:srgbClr val="555555"/>
                 </a:solidFill>
-                <a:latin typeface="Calibri"/>
+                <a:latin typeface="Fira Sans"/>
               </a:rPr>
               <a:t>● </a:t>
             </a:r>
             <a:r>
-              <a:rPr sz="750" b="1">
+              <a:rPr sz="1700" b="1">
                 <a:solidFill>
                   <a:srgbClr val="555555"/>
                 </a:solidFill>
-                <a:latin typeface="Calibri"/>
+                <a:latin typeface="Fira Sans"/>
               </a:rPr>
               <a:t>PLANNED</a:t>
             </a:r>
@@ -7290,8 +7290,8 @@
         </p:nvSpPr>
         <p:spPr>
           <a:xfrm>
-            <a:off x="3266694" y="1298448"/>
-            <a:ext cx="2736341" cy="150875"/>
+            <a:off x="3330702" y="1810512"/>
+            <a:ext cx="2644901" cy="256031"/>
           </a:xfrm>
           <a:prstGeom prst="rect">
             <a:avLst/>
@@ -7305,11 +7305,11 @@
           <a:lstStyle/>
           <a:p>
             <a:r>
-              <a:rPr sz="750" b="0">
+              <a:rPr sz="1700" b="0">
                 <a:solidFill>
                   <a:srgbClr val="3D3D3D"/>
                 </a:solidFill>
-                <a:latin typeface="Calibri"/>
+                <a:latin typeface="Fira Sans"/>
               </a:rPr>
               <a:t>Config-driven backend URL resolution (Check &amp; Care SDK)</a:t>
             </a:r>
@@ -7324,8 +7324,8 @@
         </p:nvSpPr>
         <p:spPr>
           <a:xfrm>
-            <a:off x="3266694" y="1431036"/>
-            <a:ext cx="2736341" cy="150875"/>
+            <a:off x="3330702" y="2029968"/>
+            <a:ext cx="2644901" cy="256031"/>
           </a:xfrm>
           <a:prstGeom prst="rect">
             <a:avLst/>
@@ -7339,11 +7339,11 @@
           <a:lstStyle/>
           <a:p>
             <a:r>
-              <a:rPr sz="750" b="0">
+              <a:rPr sz="1700" b="0">
                 <a:solidFill>
                   <a:srgbClr val="3D3D3D"/>
                 </a:solidFill>
-                <a:latin typeface="Calibri"/>
+                <a:latin typeface="Fira Sans"/>
               </a:rPr>
               <a:t>Datadog monitoring migration &amp; shared library alignment</a:t>
             </a:r>
@@ -7358,8 +7358,8 @@
         </p:nvSpPr>
         <p:spPr>
           <a:xfrm>
-            <a:off x="3138678" y="1636776"/>
-            <a:ext cx="2864358" cy="173736"/>
+            <a:off x="3166110" y="2377440"/>
+            <a:ext cx="2809494" cy="274320"/>
           </a:xfrm>
           <a:prstGeom prst="rect">
             <a:avLst/>
@@ -7374,11 +7374,11 @@
           <a:p>
             <a:pPr algn="l"/>
             <a:r>
-              <a:rPr sz="850" b="1" i="0">
+              <a:rPr sz="1900" b="1" i="0">
                 <a:solidFill>
                   <a:srgbClr val="1A1A2E"/>
                 </a:solidFill>
-                <a:latin typeface="Calibri"/>
+                <a:latin typeface="Fira Sans"/>
               </a:rPr>
               <a:t>Production Monitoring</a:t>
             </a:r>
@@ -7393,8 +7393,8 @@
         </p:nvSpPr>
         <p:spPr>
           <a:xfrm>
-            <a:off x="3138678" y="1810512"/>
-            <a:ext cx="2864358" cy="146304"/>
+            <a:off x="3166110" y="2651760"/>
+            <a:ext cx="2809494" cy="237744"/>
           </a:xfrm>
           <a:prstGeom prst="rect">
             <a:avLst/>
@@ -7408,20 +7408,20 @@
           <a:lstStyle/>
           <a:p>
             <a:r>
-              <a:rPr sz="750" b="1">
+              <a:rPr sz="1700" b="1">
                 <a:solidFill>
                   <a:srgbClr val="1565C0"/>
                 </a:solidFill>
-                <a:latin typeface="Calibri"/>
+                <a:latin typeface="Fira Sans"/>
               </a:rPr>
               <a:t>● </a:t>
             </a:r>
             <a:r>
-              <a:rPr sz="750" b="1">
+              <a:rPr sz="1700" b="1">
                 <a:solidFill>
                   <a:srgbClr val="1565C0"/>
                 </a:solidFill>
-                <a:latin typeface="Calibri"/>
+                <a:latin typeface="Fira Sans"/>
               </a:rPr>
               <a:t>IN PROGRESS</a:t>
             </a:r>
@@ -7436,8 +7436,8 @@
         </p:nvSpPr>
         <p:spPr>
           <a:xfrm>
-            <a:off x="3266694" y="1956816"/>
-            <a:ext cx="2736341" cy="150875"/>
+            <a:off x="3330702" y="2889504"/>
+            <a:ext cx="2644901" cy="256031"/>
           </a:xfrm>
           <a:prstGeom prst="rect">
             <a:avLst/>
@@ -7451,11 +7451,11 @@
           <a:lstStyle/>
           <a:p>
             <a:r>
-              <a:rPr sz="750" b="0">
+              <a:rPr sz="1700" b="0">
                 <a:solidFill>
                   <a:srgbClr val="3D3D3D"/>
                 </a:solidFill>
-                <a:latin typeface="Calibri"/>
+                <a:latin typeface="Fira Sans"/>
               </a:rPr>
               <a:t>Sprint 48 production log monitoring &amp; alerting</a:t>
             </a:r>
@@ -7470,8 +7470,8 @@
         </p:nvSpPr>
         <p:spPr>
           <a:xfrm>
-            <a:off x="6094476" y="658368"/>
-            <a:ext cx="10972" cy="5925312"/>
+            <a:off x="6094476" y="749808"/>
+            <a:ext cx="10972" cy="5788152"/>
           </a:xfrm>
           <a:prstGeom prst="rect">
             <a:avLst/>
@@ -7513,8 +7513,8 @@
         </p:nvSpPr>
         <p:spPr>
           <a:xfrm>
-            <a:off x="6185916" y="749808"/>
-            <a:ext cx="2864358" cy="22860"/>
+            <a:off x="6213348" y="859536"/>
+            <a:ext cx="2809494" cy="27432"/>
           </a:xfrm>
           <a:prstGeom prst="rect">
             <a:avLst/>
@@ -7556,8 +7556,8 @@
         </p:nvSpPr>
         <p:spPr>
           <a:xfrm>
-            <a:off x="6185916" y="777240"/>
-            <a:ext cx="2864358" cy="182880"/>
+            <a:off x="6213348" y="896112"/>
+            <a:ext cx="2809494" cy="310896"/>
           </a:xfrm>
           <a:prstGeom prst="rect">
             <a:avLst/>
@@ -7572,11 +7572,11 @@
           <a:p>
             <a:pPr algn="l"/>
             <a:r>
-              <a:rPr sz="800" b="1" i="0">
+              <a:rPr sz="2200" b="1" i="0">
                 <a:solidFill>
                   <a:srgbClr val="1B2A4A"/>
                 </a:solidFill>
-                <a:latin typeface="Calibri"/>
+                <a:latin typeface="Fira Sans"/>
               </a:rPr>
               <a:t>DEVOPS &amp; SDK MANAGER</a:t>
             </a:r>
@@ -7591,8 +7591,8 @@
         </p:nvSpPr>
         <p:spPr>
           <a:xfrm>
-            <a:off x="6185916" y="960120"/>
-            <a:ext cx="2864358" cy="7315"/>
+            <a:off x="6213348" y="1207008"/>
+            <a:ext cx="2809494" cy="9144"/>
           </a:xfrm>
           <a:prstGeom prst="rect">
             <a:avLst/>
@@ -7634,8 +7634,8 @@
         </p:nvSpPr>
         <p:spPr>
           <a:xfrm>
-            <a:off x="6185916" y="978408"/>
-            <a:ext cx="2864358" cy="173736"/>
+            <a:off x="6213348" y="1298448"/>
+            <a:ext cx="2809494" cy="274320"/>
           </a:xfrm>
           <a:prstGeom prst="rect">
             <a:avLst/>
@@ -7650,11 +7650,11 @@
           <a:p>
             <a:pPr algn="l"/>
             <a:r>
-              <a:rPr sz="850" b="1" i="0">
+              <a:rPr sz="1900" b="1" i="0">
                 <a:solidFill>
                   <a:srgbClr val="1A1A2E"/>
                 </a:solidFill>
-                <a:latin typeface="Calibri"/>
+                <a:latin typeface="Fira Sans"/>
               </a:rPr>
               <a:t>DevOps – Apply DevOps Practices</a:t>
             </a:r>
@@ -7669,8 +7669,8 @@
         </p:nvSpPr>
         <p:spPr>
           <a:xfrm>
-            <a:off x="6185916" y="1152144"/>
-            <a:ext cx="2864358" cy="146304"/>
+            <a:off x="6213348" y="1572768"/>
+            <a:ext cx="2809494" cy="237744"/>
           </a:xfrm>
           <a:prstGeom prst="rect">
             <a:avLst/>
@@ -7684,20 +7684,20 @@
           <a:lstStyle/>
           <a:p>
             <a:r>
-              <a:rPr sz="750" b="1">
+              <a:rPr sz="1700" b="1">
                 <a:solidFill>
                   <a:srgbClr val="1565C0"/>
                 </a:solidFill>
-                <a:latin typeface="Calibri"/>
+                <a:latin typeface="Fira Sans"/>
               </a:rPr>
               <a:t>● </a:t>
             </a:r>
             <a:r>
-              <a:rPr sz="750" b="1">
+              <a:rPr sz="1700" b="1">
                 <a:solidFill>
                   <a:srgbClr val="1565C0"/>
                 </a:solidFill>
-                <a:latin typeface="Calibri"/>
+                <a:latin typeface="Fira Sans"/>
               </a:rPr>
               <a:t>IN PROGRESS</a:t>
             </a:r>
@@ -7712,8 +7712,8 @@
         </p:nvSpPr>
         <p:spPr>
           <a:xfrm>
-            <a:off x="6313931" y="1298448"/>
-            <a:ext cx="2736341" cy="150875"/>
+            <a:off x="6377940" y="1810512"/>
+            <a:ext cx="2644901" cy="256031"/>
           </a:xfrm>
           <a:prstGeom prst="rect">
             <a:avLst/>
@@ -7727,11 +7727,11 @@
           <a:lstStyle/>
           <a:p>
             <a:r>
-              <a:rPr sz="750" b="0">
+              <a:rPr sz="1700" b="0">
                 <a:solidFill>
                   <a:srgbClr val="3D3D3D"/>
                 </a:solidFill>
-                <a:latin typeface="Calibri"/>
+                <a:latin typeface="Fira Sans"/>
               </a:rPr>
               <a:t>Sprint 48 CI/CD workflow maintenance &amp; fixes</a:t>
             </a:r>
@@ -7746,8 +7746,8 @@
         </p:nvSpPr>
         <p:spPr>
           <a:xfrm>
-            <a:off x="6313931" y="1431036"/>
-            <a:ext cx="2736341" cy="150875"/>
+            <a:off x="6377940" y="2029968"/>
+            <a:ext cx="2644901" cy="256031"/>
           </a:xfrm>
           <a:prstGeom prst="rect">
             <a:avLst/>
@@ -7761,11 +7761,11 @@
           <a:lstStyle/>
           <a:p>
             <a:r>
-              <a:rPr sz="750" b="0">
+              <a:rPr sz="1700" b="0">
                 <a:solidFill>
                   <a:srgbClr val="3D3D3D"/>
                 </a:solidFill>
-                <a:latin typeface="Calibri"/>
+                <a:latin typeface="Fira Sans"/>
               </a:rPr>
               <a:t>Azure infrastructure provisioning automation discovery</a:t>
             </a:r>
@@ -7780,8 +7780,8 @@
         </p:nvSpPr>
         <p:spPr>
           <a:xfrm>
-            <a:off x="6185916" y="1636776"/>
-            <a:ext cx="2864358" cy="173736"/>
+            <a:off x="6213348" y="2377440"/>
+            <a:ext cx="2809494" cy="274320"/>
           </a:xfrm>
           <a:prstGeom prst="rect">
             <a:avLst/>
@@ -7796,11 +7796,11 @@
           <a:p>
             <a:pPr algn="l"/>
             <a:r>
-              <a:rPr sz="850" b="1" i="0">
+              <a:rPr sz="1900" b="1" i="0">
                 <a:solidFill>
                   <a:srgbClr val="1A1A2E"/>
                 </a:solidFill>
-                <a:latin typeface="Calibri"/>
+                <a:latin typeface="Fira Sans"/>
               </a:rPr>
               <a:t>SDK Manager – Misc Enhancements</a:t>
             </a:r>
@@ -7815,8 +7815,8 @@
         </p:nvSpPr>
         <p:spPr>
           <a:xfrm>
-            <a:off x="6185916" y="1810512"/>
-            <a:ext cx="2864358" cy="146304"/>
+            <a:off x="6213348" y="2651760"/>
+            <a:ext cx="2809494" cy="237744"/>
           </a:xfrm>
           <a:prstGeom prst="rect">
             <a:avLst/>
@@ -7830,20 +7830,20 @@
           <a:lstStyle/>
           <a:p>
             <a:r>
-              <a:rPr sz="750" b="1">
+              <a:rPr sz="1700" b="1">
                 <a:solidFill>
                   <a:srgbClr val="2E7D32"/>
                 </a:solidFill>
-                <a:latin typeface="Calibri"/>
+                <a:latin typeface="Fira Sans"/>
               </a:rPr>
               <a:t>● </a:t>
             </a:r>
             <a:r>
-              <a:rPr sz="750" b="1">
+              <a:rPr sz="1700" b="1">
                 <a:solidFill>
                   <a:srgbClr val="2E7D32"/>
                 </a:solidFill>
-                <a:latin typeface="Calibri"/>
+                <a:latin typeface="Fira Sans"/>
               </a:rPr>
               <a:t>COMPLETED</a:t>
             </a:r>
@@ -7858,8 +7858,8 @@
         </p:nvSpPr>
         <p:spPr>
           <a:xfrm>
-            <a:off x="6313931" y="1956816"/>
-            <a:ext cx="2736341" cy="150875"/>
+            <a:off x="6377940" y="2889504"/>
+            <a:ext cx="2644901" cy="256031"/>
           </a:xfrm>
           <a:prstGeom prst="rect">
             <a:avLst/>
@@ -7873,11 +7873,11 @@
           <a:lstStyle/>
           <a:p>
             <a:r>
-              <a:rPr sz="750" b="0">
+              <a:rPr sz="1700" b="0">
                 <a:solidFill>
                   <a:srgbClr val="3D3D3D"/>
                 </a:solidFill>
-                <a:latin typeface="Calibri"/>
+                <a:latin typeface="Fira Sans"/>
               </a:rPr>
               <a:t>Variant Configurations view (backend) delivered</a:t>
             </a:r>
@@ -7892,8 +7892,8 @@
         </p:nvSpPr>
         <p:spPr>
           <a:xfrm>
-            <a:off x="6185916" y="2089404"/>
-            <a:ext cx="2864358" cy="146304"/>
+            <a:off x="6213348" y="3108960"/>
+            <a:ext cx="2809494" cy="237744"/>
           </a:xfrm>
           <a:prstGeom prst="rect">
             <a:avLst/>
@@ -7907,20 +7907,20 @@
           <a:lstStyle/>
           <a:p>
             <a:r>
-              <a:rPr sz="750" b="1">
+              <a:rPr sz="1700" b="1">
                 <a:solidFill>
                   <a:srgbClr val="1565C0"/>
                 </a:solidFill>
-                <a:latin typeface="Calibri"/>
+                <a:latin typeface="Fira Sans"/>
               </a:rPr>
               <a:t>● </a:t>
             </a:r>
             <a:r>
-              <a:rPr sz="750" b="1">
+              <a:rPr sz="1700" b="1">
                 <a:solidFill>
                   <a:srgbClr val="1565C0"/>
                 </a:solidFill>
-                <a:latin typeface="Calibri"/>
+                <a:latin typeface="Fira Sans"/>
               </a:rPr>
               <a:t>IN PROGRESS</a:t>
             </a:r>
@@ -7935,8 +7935,8 @@
         </p:nvSpPr>
         <p:spPr>
           <a:xfrm>
-            <a:off x="6313931" y="2235708"/>
-            <a:ext cx="2736341" cy="150875"/>
+            <a:off x="6377940" y="3346704"/>
+            <a:ext cx="2644901" cy="402336"/>
           </a:xfrm>
           <a:prstGeom prst="rect">
             <a:avLst/>
@@ -7950,11 +7950,11 @@
           <a:lstStyle/>
           <a:p>
             <a:r>
-              <a:rPr sz="750" b="0">
+              <a:rPr sz="1700" b="0">
                 <a:solidFill>
                   <a:srgbClr val="3D3D3D"/>
                 </a:solidFill>
-                <a:latin typeface="Calibri"/>
+                <a:latin typeface="Fira Sans"/>
               </a:rPr>
               <a:t>Environment banner in SDK Manager header (Dev/Stage/PreProd/Prod)</a:t>
             </a:r>
@@ -7969,8 +7969,8 @@
         </p:nvSpPr>
         <p:spPr>
           <a:xfrm>
-            <a:off x="6313931" y="2368296"/>
-            <a:ext cx="2736341" cy="150875"/>
+            <a:off x="6377940" y="3712464"/>
+            <a:ext cx="2644901" cy="256031"/>
           </a:xfrm>
           <a:prstGeom prst="rect">
             <a:avLst/>
@@ -7984,11 +7984,11 @@
           <a:lstStyle/>
           <a:p>
             <a:r>
-              <a:rPr sz="750" b="0">
+              <a:rPr sz="1700" b="0">
                 <a:solidFill>
                   <a:srgbClr val="3D3D3D"/>
                 </a:solidFill>
-                <a:latin typeface="Calibri"/>
+                <a:latin typeface="Fira Sans"/>
               </a:rPr>
               <a:t>Bundle validation alert when deleting assigned bundles</a:t>
             </a:r>
@@ -8003,8 +8003,8 @@
         </p:nvSpPr>
         <p:spPr>
           <a:xfrm>
-            <a:off x="6313931" y="2500884"/>
-            <a:ext cx="2736341" cy="150875"/>
+            <a:off x="6377940" y="3931920"/>
+            <a:ext cx="2644901" cy="256031"/>
           </a:xfrm>
           <a:prstGeom prst="rect">
             <a:avLst/>
@@ -8018,11 +8018,11 @@
           <a:lstStyle/>
           <a:p>
             <a:r>
-              <a:rPr sz="750" b="0">
+              <a:rPr sz="1700" b="0">
                 <a:solidFill>
                   <a:srgbClr val="3D3D3D"/>
                 </a:solidFill>
-                <a:latin typeface="Calibri"/>
+                <a:latin typeface="Fira Sans"/>
               </a:rPr>
               <a:t>Calendar UI fix for Anicura SDK date entry</a:t>
             </a:r>
@@ -8037,8 +8037,8 @@
         </p:nvSpPr>
         <p:spPr>
           <a:xfrm>
-            <a:off x="6313931" y="2633472"/>
-            <a:ext cx="2736341" cy="150875"/>
+            <a:off x="6377940" y="4151376"/>
+            <a:ext cx="2644901" cy="256031"/>
           </a:xfrm>
           <a:prstGeom prst="rect">
             <a:avLst/>
@@ -8052,11 +8052,11 @@
           <a:lstStyle/>
           <a:p>
             <a:r>
-              <a:rPr sz="750" b="0">
+              <a:rPr sz="1700" b="0">
                 <a:solidFill>
                   <a:srgbClr val="3D3D3D"/>
                 </a:solidFill>
-                <a:latin typeface="Calibri"/>
+                <a:latin typeface="Fira Sans"/>
               </a:rPr>
               <a:t>Bundle Draft status display correction</a:t>
             </a:r>
@@ -8071,8 +8071,8 @@
         </p:nvSpPr>
         <p:spPr>
           <a:xfrm>
-            <a:off x="9141714" y="658368"/>
-            <a:ext cx="10972" cy="5925312"/>
+            <a:off x="9141714" y="749808"/>
+            <a:ext cx="10972" cy="5788152"/>
           </a:xfrm>
           <a:prstGeom prst="rect">
             <a:avLst/>
@@ -8114,8 +8114,8 @@
         </p:nvSpPr>
         <p:spPr>
           <a:xfrm>
-            <a:off x="9233154" y="749808"/>
-            <a:ext cx="2864358" cy="22860"/>
+            <a:off x="9260586" y="859536"/>
+            <a:ext cx="2809494" cy="27432"/>
           </a:xfrm>
           <a:prstGeom prst="rect">
             <a:avLst/>
@@ -8157,8 +8157,8 @@
         </p:nvSpPr>
         <p:spPr>
           <a:xfrm>
-            <a:off x="9233154" y="777240"/>
-            <a:ext cx="2864358" cy="182880"/>
+            <a:off x="9260586" y="896112"/>
+            <a:ext cx="2809494" cy="310896"/>
           </a:xfrm>
           <a:prstGeom prst="rect">
             <a:avLst/>
@@ -8173,11 +8173,11 @@
           <a:p>
             <a:pPr algn="l"/>
             <a:r>
-              <a:rPr sz="800" b="1" i="0">
+              <a:rPr sz="2200" b="1" i="0">
                 <a:solidFill>
                   <a:srgbClr val="1B2A4A"/>
                 </a:solidFill>
-                <a:latin typeface="Calibri"/>
+                <a:latin typeface="Fira Sans"/>
               </a:rPr>
               <a:t>QA &amp; CROSS-CUTTING</a:t>
             </a:r>
@@ -8192,8 +8192,8 @@
         </p:nvSpPr>
         <p:spPr>
           <a:xfrm>
-            <a:off x="9233154" y="960120"/>
-            <a:ext cx="2864358" cy="7315"/>
+            <a:off x="9260586" y="1207008"/>
+            <a:ext cx="2809494" cy="9144"/>
           </a:xfrm>
           <a:prstGeom prst="rect">
             <a:avLst/>
@@ -8235,8 +8235,8 @@
         </p:nvSpPr>
         <p:spPr>
           <a:xfrm>
-            <a:off x="9233154" y="978408"/>
-            <a:ext cx="2864358" cy="173736"/>
+            <a:off x="9260586" y="1298448"/>
+            <a:ext cx="2809494" cy="274320"/>
           </a:xfrm>
           <a:prstGeom prst="rect">
             <a:avLst/>
@@ -8251,11 +8251,11 @@
           <a:p>
             <a:pPr algn="l"/>
             <a:r>
-              <a:rPr sz="850" b="1" i="0">
+              <a:rPr sz="1900" b="1" i="0">
                 <a:solidFill>
                   <a:srgbClr val="1A1A2E"/>
                 </a:solidFill>
-                <a:latin typeface="Calibri"/>
+                <a:latin typeface="Fira Sans"/>
               </a:rPr>
               <a:t>QA Activities – Sprint 48</a:t>
             </a:r>
@@ -8270,8 +8270,8 @@
         </p:nvSpPr>
         <p:spPr>
           <a:xfrm>
-            <a:off x="9233154" y="1152144"/>
-            <a:ext cx="2864358" cy="146304"/>
+            <a:off x="9260586" y="1572768"/>
+            <a:ext cx="2809494" cy="237744"/>
           </a:xfrm>
           <a:prstGeom prst="rect">
             <a:avLst/>
@@ -8285,20 +8285,20 @@
           <a:lstStyle/>
           <a:p>
             <a:r>
-              <a:rPr sz="750" b="1">
+              <a:rPr sz="1700" b="1">
                 <a:solidFill>
                   <a:srgbClr val="1565C0"/>
                 </a:solidFill>
-                <a:latin typeface="Calibri"/>
+                <a:latin typeface="Fira Sans"/>
               </a:rPr>
               <a:t>● </a:t>
             </a:r>
             <a:r>
-              <a:rPr sz="750" b="1">
+              <a:rPr sz="1700" b="1">
                 <a:solidFill>
                   <a:srgbClr val="1565C0"/>
                 </a:solidFill>
-                <a:latin typeface="Calibri"/>
+                <a:latin typeface="Fira Sans"/>
               </a:rPr>
               <a:t>IN PROGRESS</a:t>
             </a:r>
@@ -8313,8 +8313,8 @@
         </p:nvSpPr>
         <p:spPr>
           <a:xfrm>
-            <a:off x="9361170" y="1298448"/>
-            <a:ext cx="2736341" cy="150875"/>
+            <a:off x="9425178" y="1810512"/>
+            <a:ext cx="2644901" cy="256031"/>
           </a:xfrm>
           <a:prstGeom prst="rect">
             <a:avLst/>
@@ -8328,11 +8328,11 @@
           <a:lstStyle/>
           <a:p>
             <a:r>
-              <a:rPr sz="750" b="0">
+              <a:rPr sz="1700" b="0">
                 <a:solidFill>
                   <a:srgbClr val="3D3D3D"/>
                 </a:solidFill>
-                <a:latin typeface="Calibri"/>
+                <a:latin typeface="Fira Sans"/>
               </a:rPr>
               <a:t>Integration testing for ToothScan 2.0</a:t>
             </a:r>
@@ -8347,8 +8347,8 @@
         </p:nvSpPr>
         <p:spPr>
           <a:xfrm>
-            <a:off x="9361170" y="1431036"/>
-            <a:ext cx="2736341" cy="150875"/>
+            <a:off x="9425178" y="2029968"/>
+            <a:ext cx="2644901" cy="256031"/>
           </a:xfrm>
           <a:prstGeom prst="rect">
             <a:avLst/>
@@ -8362,11 +8362,11 @@
           <a:lstStyle/>
           <a:p>
             <a:r>
-              <a:rPr sz="750" b="0">
+              <a:rPr sz="1700" b="0">
                 <a:solidFill>
                   <a:srgbClr val="3D3D3D"/>
                 </a:solidFill>
-                <a:latin typeface="Calibri"/>
+                <a:latin typeface="Fira Sans"/>
               </a:rPr>
               <a:t>GA tag verification for ToothScan 2.0 user journey</a:t>
             </a:r>
@@ -8381,8 +8381,8 @@
         </p:nvSpPr>
         <p:spPr>
           <a:xfrm>
-            <a:off x="9361170" y="1563624"/>
-            <a:ext cx="2736341" cy="150875"/>
+            <a:off x="9425178" y="2249424"/>
+            <a:ext cx="2644901" cy="256031"/>
           </a:xfrm>
           <a:prstGeom prst="rect">
             <a:avLst/>
@@ -8396,11 +8396,11 @@
           <a:lstStyle/>
           <a:p>
             <a:r>
-              <a:rPr sz="750" b="0">
+              <a:rPr sz="1700" b="0">
                 <a:solidFill>
                   <a:srgbClr val="3D3D3D"/>
                 </a:solidFill>
-                <a:latin typeface="Calibri"/>
+                <a:latin typeface="Fira Sans"/>
               </a:rPr>
               <a:t>Image upload scenario verification for ToothScan</a:t>
             </a:r>
@@ -8415,8 +8415,8 @@
         </p:nvSpPr>
         <p:spPr>
           <a:xfrm>
-            <a:off x="9233154" y="1769364"/>
-            <a:ext cx="2864358" cy="173736"/>
+            <a:off x="9260586" y="2596896"/>
+            <a:ext cx="2809494" cy="274320"/>
           </a:xfrm>
           <a:prstGeom prst="rect">
             <a:avLst/>
@@ -8431,11 +8431,11 @@
           <a:p>
             <a:pPr algn="l"/>
             <a:r>
-              <a:rPr sz="850" b="1" i="0">
+              <a:rPr sz="1900" b="1" i="0">
                 <a:solidFill>
                   <a:srgbClr val="1A1A2E"/>
                 </a:solidFill>
-                <a:latin typeface="Calibri"/>
+                <a:latin typeface="Fira Sans"/>
               </a:rPr>
               <a:t>Config ID – SDK App Context</a:t>
             </a:r>
@@ -8450,8 +8450,8 @@
         </p:nvSpPr>
         <p:spPr>
           <a:xfrm>
-            <a:off x="9233154" y="1943100"/>
-            <a:ext cx="2864358" cy="146304"/>
+            <a:off x="9260586" y="2871216"/>
+            <a:ext cx="2809494" cy="237744"/>
           </a:xfrm>
           <a:prstGeom prst="rect">
             <a:avLst/>
@@ -8465,20 +8465,20 @@
           <a:lstStyle/>
           <a:p>
             <a:r>
-              <a:rPr sz="750" b="1">
+              <a:rPr sz="1700" b="1">
                 <a:solidFill>
                   <a:srgbClr val="1565C0"/>
                 </a:solidFill>
-                <a:latin typeface="Calibri"/>
+                <a:latin typeface="Fira Sans"/>
               </a:rPr>
               <a:t>● </a:t>
             </a:r>
             <a:r>
-              <a:rPr sz="750" b="1">
+              <a:rPr sz="1700" b="1">
                 <a:solidFill>
                   <a:srgbClr val="1565C0"/>
                 </a:solidFill>
-                <a:latin typeface="Calibri"/>
+                <a:latin typeface="Fira Sans"/>
               </a:rPr>
               <a:t>IN PROGRESS</a:t>
             </a:r>
@@ -8493,8 +8493,8 @@
         </p:nvSpPr>
         <p:spPr>
           <a:xfrm>
-            <a:off x="9361170" y="2089404"/>
-            <a:ext cx="2736341" cy="150875"/>
+            <a:off x="9425178" y="3108960"/>
+            <a:ext cx="2644901" cy="402336"/>
           </a:xfrm>
           <a:prstGeom prst="rect">
             <a:avLst/>
@@ -8508,11 +8508,11 @@
           <a:lstStyle/>
           <a:p>
             <a:r>
-              <a:rPr sz="750" b="0">
+              <a:rPr sz="1700" b="0">
                 <a:solidFill>
                   <a:srgbClr val="3D3D3D"/>
                 </a:solidFill>
-                <a:latin typeface="Calibri"/>
+                <a:latin typeface="Fira Sans"/>
               </a:rPr>
               <a:t>Config ID integration in SDK app context across API requests</a:t>
             </a:r>
@@ -8527,8 +8527,8 @@
         </p:nvSpPr>
         <p:spPr>
           <a:xfrm>
-            <a:off x="9233154" y="2221992"/>
-            <a:ext cx="2864358" cy="146304"/>
+            <a:off x="9260586" y="3474720"/>
+            <a:ext cx="2809494" cy="237744"/>
           </a:xfrm>
           <a:prstGeom prst="rect">
             <a:avLst/>
@@ -8542,20 +8542,20 @@
           <a:lstStyle/>
           <a:p>
             <a:r>
-              <a:rPr sz="750" b="1">
+              <a:rPr sz="1700" b="1">
                 <a:solidFill>
                   <a:srgbClr val="555555"/>
                 </a:solidFill>
-                <a:latin typeface="Calibri"/>
+                <a:latin typeface="Fira Sans"/>
               </a:rPr>
               <a:t>● </a:t>
             </a:r>
             <a:r>
-              <a:rPr sz="750" b="1">
+              <a:rPr sz="1700" b="1">
                 <a:solidFill>
                   <a:srgbClr val="555555"/>
                 </a:solidFill>
-                <a:latin typeface="Calibri"/>
+                <a:latin typeface="Fira Sans"/>
               </a:rPr>
               <a:t>PLANNED</a:t>
             </a:r>
@@ -8570,8 +8570,8 @@
         </p:nvSpPr>
         <p:spPr>
           <a:xfrm>
-            <a:off x="9361170" y="2368296"/>
-            <a:ext cx="2736341" cy="150875"/>
+            <a:off x="9425178" y="3712464"/>
+            <a:ext cx="2644901" cy="256031"/>
           </a:xfrm>
           <a:prstGeom prst="rect">
             <a:avLst/>
@@ -8585,11 +8585,11 @@
           <a:lstStyle/>
           <a:p>
             <a:r>
-              <a:rPr sz="750" b="0">
+              <a:rPr sz="1700" b="0">
                 <a:solidFill>
                   <a:srgbClr val="3D3D3D"/>
                 </a:solidFill>
-                <a:latin typeface="Calibri"/>
+                <a:latin typeface="Fira Sans"/>
               </a:rPr>
               <a:t>Demo application Config ID-based SDK launch support</a:t>
             </a:r>
@@ -8604,8 +8604,8 @@
         </p:nvSpPr>
         <p:spPr>
           <a:xfrm>
-            <a:off x="9361170" y="2500884"/>
-            <a:ext cx="2736341" cy="150875"/>
+            <a:off x="9425178" y="3931920"/>
+            <a:ext cx="2644901" cy="402336"/>
           </a:xfrm>
           <a:prstGeom prst="rect">
             <a:avLst/>
@@ -8619,11 +8619,11 @@
           <a:lstStyle/>
           <a:p>
             <a:r>
-              <a:rPr sz="750" b="0">
+              <a:rPr sz="1700" b="0">
                 <a:solidFill>
                   <a:srgbClr val="3D3D3D"/>
                 </a:solidFill>
-                <a:latin typeface="Calibri"/>
+                <a:latin typeface="Fira Sans"/>
               </a:rPr>
               <a:t>Weight range updates for Puppy &amp; Kitten Weight Check tools</a:t>
             </a:r>

</xml_diff>